<commit_message>
checkpoint before checking out main
</commit_message>
<xml_diff>
--- a/docs/J人模拟器2.0_发布会.pptx
+++ b/docs/J人模拟器2.0_发布会.pptx
@@ -1,20 +1,23 @@
 
 <file path=ppt/presentation.xml><?xml version="1.0" encoding="utf-8"?>
-<p:presentation xmlns:a="http://schemas.openxmlformats.org/drawingml/2006/main" xmlns:r="http://schemas.openxmlformats.org/officeDocument/2006/relationships" xmlns:p="http://schemas.openxmlformats.org/presentationml/2006/main" saveSubsetFonts="1" autoCompressPictures="0">
+<p:presentation xmlns:a="http://schemas.openxmlformats.org/drawingml/2006/main" xmlns:r="http://schemas.openxmlformats.org/officeDocument/2006/relationships" xmlns:p="http://schemas.openxmlformats.org/presentationml/2006/main" autoCompressPictures="0">
   <p:sldMasterIdLst>
     <p:sldMasterId id="2147483648" r:id="rId1"/>
   </p:sldMasterIdLst>
+  <p:notesMasterIdLst>
+    <p:notesMasterId r:id="rId4"/>
+  </p:notesMasterIdLst>
   <p:sldIdLst>
-    <p:sldId id="256" r:id="rId7"/>
-    <p:sldId id="257" r:id="rId9"/>
-    <p:sldId id="258" r:id="rId10"/>
-    <p:sldId id="259" r:id="rId11"/>
-    <p:sldId id="260" r:id="rId12"/>
-    <p:sldId id="261" r:id="rId13"/>
-    <p:sldId id="262" r:id="rId14"/>
-    <p:sldId id="263" r:id="rId15"/>
+    <p:sldId id="256" r:id="rId3"/>
+    <p:sldId id="257" r:id="rId5"/>
+    <p:sldId id="258" r:id="rId6"/>
+    <p:sldId id="259" r:id="rId7"/>
+    <p:sldId id="260" r:id="rId8"/>
+    <p:sldId id="262" r:id="rId9"/>
+    <p:sldId id="261" r:id="rId10"/>
+    <p:sldId id="263" r:id="rId11"/>
   </p:sldIdLst>
-  <p:sldSz cx="12191695" cy="6858000" type="screen4x3"/>
+  <p:sldSz cx="12191365" cy="6858000" type="screen4x3"/>
   <p:notesSz cx="6858000" cy="9144000"/>
   <p:defaultTextStyle>
     <a:defPPr>
@@ -111,11 +114,27 @@
       </a:defRPr>
     </a:lvl9pPr>
   </p:defaultTextStyle>
+  <p:extLst>
+    <p:ext uri="{EFAFB233-063F-42B5-8137-9DF3F51BA10A}">
+      <p15:sldGuideLst xmlns:p15="http://schemas.microsoft.com/office/powerpoint/2012/main">
+        <p15:guide id="1" orient="horz" pos="2160" userDrawn="1">
+          <p15:clr>
+            <a:srgbClr val="A4A3A4"/>
+          </p15:clr>
+        </p15:guide>
+        <p15:guide id="2" pos="2880" userDrawn="1">
+          <p15:clr>
+            <a:srgbClr val="A4A3A4"/>
+          </p15:clr>
+        </p15:guide>
+      </p15:sldGuideLst>
+    </p:ext>
+  </p:extLst>
 </p:presentation>
 </file>
 
 <file path=ppt/notesMasters/notesMaster1.xml><?xml version="1.0" encoding="utf-8"?>
-<p:notesMaster xmlns:a="http://schemas.openxmlformats.org/drawingml/2006/main" xmlns:p="http://schemas.openxmlformats.org/presentationml/2006/main" xmlns:r="http://schemas.openxmlformats.org/officeDocument/2006/relationships">
+<p:notesMaster xmlns:a="http://schemas.openxmlformats.org/drawingml/2006/main" xmlns:r="http://schemas.openxmlformats.org/officeDocument/2006/relationships" xmlns:p="http://schemas.openxmlformats.org/presentationml/2006/main">
   <p:cSld>
     <p:bg>
       <p:bgRef idx="1001">
@@ -196,7 +215,6 @@
           <a:p>
             <a:fld id="{0F89C1C7-3DCD-1040-A9CF-14679D8B5DDD}" type="datetimeFigureOut">
               <a:rPr lang="en-US" smtClean="0"/>
-              <a:t>10/17/16</a:t>
             </a:fld>
             <a:endParaRPr lang="en-US"/>
           </a:p>
@@ -263,6 +281,7 @@
               <a:rPr lang="en-US" smtClean="0"/>
               <a:t>Click to edit Master text styles</a:t>
             </a:r>
+            <a:endParaRPr lang="en-US" smtClean="0"/>
           </a:p>
           <a:p>
             <a:pPr lvl="1"/>
@@ -270,6 +289,7 @@
               <a:rPr lang="en-US" smtClean="0"/>
               <a:t>Second level</a:t>
             </a:r>
+            <a:endParaRPr lang="en-US" smtClean="0"/>
           </a:p>
           <a:p>
             <a:pPr lvl="2"/>
@@ -277,6 +297,7 @@
               <a:rPr lang="en-US" smtClean="0"/>
               <a:t>Third level</a:t>
             </a:r>
+            <a:endParaRPr lang="en-US" smtClean="0"/>
           </a:p>
           <a:p>
             <a:pPr lvl="3"/>
@@ -284,6 +305,7 @@
               <a:rPr lang="en-US" smtClean="0"/>
               <a:t>Fourth level</a:t>
             </a:r>
+            <a:endParaRPr lang="en-US" smtClean="0"/>
           </a:p>
           <a:p>
             <a:pPr lvl="4"/>
@@ -355,18 +377,12 @@
           <a:p>
             <a:fld id="{BB5E49A5-4136-284D-997B-48E1D791AD67}" type="slidenum">
               <a:rPr lang="en-US" smtClean="0"/>
-              <a:t>‹#›</a:t>
             </a:fld>
             <a:endParaRPr lang="en-US"/>
           </a:p>
         </p:txBody>
       </p:sp>
     </p:spTree>
-    <p:extLst>
-      <p:ext uri="{BB962C8B-B14F-4D97-AF65-F5344CB8AC3E}">
-        <p14:creationId xmlns:p14="http://schemas.microsoft.com/office/powerpoint/2010/main" val="2623252185"/>
-      </p:ext>
-    </p:extLst>
   </p:cSld>
   <p:clrMap bg1="lt1" tx1="dk1" bg2="lt2" tx2="dk2" accent1="accent1" accent2="accent2" accent3="accent3" accent4="accent4" accent5="accent5" accent6="accent6" hlink="hlink" folHlink="folHlink"/>
   <p:notesStyle>
@@ -465,7 +481,7 @@
 </file>
 
 <file path=ppt/notesSlides/notesSlide1.xml><?xml version="1.0" encoding="utf-8"?>
-<p:notes xmlns:a="http://schemas.openxmlformats.org/drawingml/2006/main" xmlns:p="http://schemas.openxmlformats.org/presentationml/2006/main" xmlns:r="http://schemas.openxmlformats.org/officeDocument/2006/relationships">
+<p:notes xmlns:a="http://schemas.openxmlformats.org/drawingml/2006/main" xmlns:r="http://schemas.openxmlformats.org/officeDocument/2006/relationships" xmlns:p="http://schemas.openxmlformats.org/presentationml/2006/main">
   <p:cSld>
     <p:spTree>
       <p:nvGrpSpPr>
@@ -500,7 +516,7 @@
             <a:spLocks noGrp="1"/>
           </p:cNvSpPr>
           <p:nvPr>
-            <p:ph type="body" idx="3" sz="quarter"/>
+            <p:ph type="body" sz="quarter" idx="3"/>
           </p:nvPr>
         </p:nvSpPr>
         <p:spPr/>
@@ -521,7 +537,7 @@
             <a:spLocks noGrp="1"/>
           </p:cNvSpPr>
           <p:nvPr>
-            <p:ph type="sldNum" idx="5" sz="quarter"/>
+            <p:ph type="sldNum" sz="quarter" idx="5"/>
           </p:nvPr>
         </p:nvSpPr>
         <p:spPr/>
@@ -535,7 +551,7 @@
 </file>
 
 <file path=ppt/notesSlides/notesSlide2.xml><?xml version="1.0" encoding="utf-8"?>
-<p:notes xmlns:a="http://schemas.openxmlformats.org/drawingml/2006/main" xmlns:p="http://schemas.openxmlformats.org/presentationml/2006/main" xmlns:r="http://schemas.openxmlformats.org/officeDocument/2006/relationships">
+<p:notes xmlns:a="http://schemas.openxmlformats.org/drawingml/2006/main" xmlns:r="http://schemas.openxmlformats.org/officeDocument/2006/relationships" xmlns:p="http://schemas.openxmlformats.org/presentationml/2006/main">
   <p:cSld>
     <p:spTree>
       <p:nvGrpSpPr>
@@ -570,7 +586,7 @@
             <a:spLocks noGrp="1"/>
           </p:cNvSpPr>
           <p:nvPr>
-            <p:ph type="body" idx="3" sz="quarter"/>
+            <p:ph type="body" sz="quarter" idx="3"/>
           </p:nvPr>
         </p:nvSpPr>
         <p:spPr/>
@@ -591,7 +607,7 @@
             <a:spLocks noGrp="1"/>
           </p:cNvSpPr>
           <p:nvPr>
-            <p:ph type="sldNum" idx="5" sz="quarter"/>
+            <p:ph type="sldNum" sz="quarter" idx="5"/>
           </p:nvPr>
         </p:nvSpPr>
         <p:spPr/>
@@ -605,7 +621,7 @@
 </file>
 
 <file path=ppt/notesSlides/notesSlide3.xml><?xml version="1.0" encoding="utf-8"?>
-<p:notes xmlns:a="http://schemas.openxmlformats.org/drawingml/2006/main" xmlns:p="http://schemas.openxmlformats.org/presentationml/2006/main" xmlns:r="http://schemas.openxmlformats.org/officeDocument/2006/relationships">
+<p:notes xmlns:a="http://schemas.openxmlformats.org/drawingml/2006/main" xmlns:r="http://schemas.openxmlformats.org/officeDocument/2006/relationships" xmlns:p="http://schemas.openxmlformats.org/presentationml/2006/main">
   <p:cSld>
     <p:spTree>
       <p:nvGrpSpPr>
@@ -640,7 +656,7 @@
             <a:spLocks noGrp="1"/>
           </p:cNvSpPr>
           <p:nvPr>
-            <p:ph type="body" idx="3" sz="quarter"/>
+            <p:ph type="body" sz="quarter" idx="3"/>
           </p:nvPr>
         </p:nvSpPr>
         <p:spPr/>
@@ -661,7 +677,7 @@
             <a:spLocks noGrp="1"/>
           </p:cNvSpPr>
           <p:nvPr>
-            <p:ph type="sldNum" idx="5" sz="quarter"/>
+            <p:ph type="sldNum" sz="quarter" idx="5"/>
           </p:nvPr>
         </p:nvSpPr>
         <p:spPr/>
@@ -675,7 +691,7 @@
 </file>
 
 <file path=ppt/notesSlides/notesSlide4.xml><?xml version="1.0" encoding="utf-8"?>
-<p:notes xmlns:a="http://schemas.openxmlformats.org/drawingml/2006/main" xmlns:p="http://schemas.openxmlformats.org/presentationml/2006/main" xmlns:r="http://schemas.openxmlformats.org/officeDocument/2006/relationships">
+<p:notes xmlns:a="http://schemas.openxmlformats.org/drawingml/2006/main" xmlns:r="http://schemas.openxmlformats.org/officeDocument/2006/relationships" xmlns:p="http://schemas.openxmlformats.org/presentationml/2006/main">
   <p:cSld>
     <p:spTree>
       <p:nvGrpSpPr>
@@ -710,7 +726,7 @@
             <a:spLocks noGrp="1"/>
           </p:cNvSpPr>
           <p:nvPr>
-            <p:ph type="body" idx="3" sz="quarter"/>
+            <p:ph type="body" sz="quarter" idx="3"/>
           </p:nvPr>
         </p:nvSpPr>
         <p:spPr/>
@@ -731,7 +747,7 @@
             <a:spLocks noGrp="1"/>
           </p:cNvSpPr>
           <p:nvPr>
-            <p:ph type="sldNum" idx="5" sz="quarter"/>
+            <p:ph type="sldNum" sz="quarter" idx="5"/>
           </p:nvPr>
         </p:nvSpPr>
         <p:spPr/>
@@ -745,7 +761,7 @@
 </file>
 
 <file path=ppt/notesSlides/notesSlide5.xml><?xml version="1.0" encoding="utf-8"?>
-<p:notes xmlns:a="http://schemas.openxmlformats.org/drawingml/2006/main" xmlns:p="http://schemas.openxmlformats.org/presentationml/2006/main" xmlns:r="http://schemas.openxmlformats.org/officeDocument/2006/relationships">
+<p:notes xmlns:a="http://schemas.openxmlformats.org/drawingml/2006/main" xmlns:r="http://schemas.openxmlformats.org/officeDocument/2006/relationships" xmlns:p="http://schemas.openxmlformats.org/presentationml/2006/main">
   <p:cSld>
     <p:spTree>
       <p:nvGrpSpPr>
@@ -780,7 +796,7 @@
             <a:spLocks noGrp="1"/>
           </p:cNvSpPr>
           <p:nvPr>
-            <p:ph type="body" idx="3" sz="quarter"/>
+            <p:ph type="body" sz="quarter" idx="3"/>
           </p:nvPr>
         </p:nvSpPr>
         <p:spPr/>
@@ -801,7 +817,7 @@
             <a:spLocks noGrp="1"/>
           </p:cNvSpPr>
           <p:nvPr>
-            <p:ph type="sldNum" idx="5" sz="quarter"/>
+            <p:ph type="sldNum" sz="quarter" idx="5"/>
           </p:nvPr>
         </p:nvSpPr>
         <p:spPr/>
@@ -815,7 +831,7 @@
 </file>
 
 <file path=ppt/notesSlides/notesSlide6.xml><?xml version="1.0" encoding="utf-8"?>
-<p:notes xmlns:a="http://schemas.openxmlformats.org/drawingml/2006/main" xmlns:p="http://schemas.openxmlformats.org/presentationml/2006/main" xmlns:r="http://schemas.openxmlformats.org/officeDocument/2006/relationships">
+<p:notes xmlns:a="http://schemas.openxmlformats.org/drawingml/2006/main" xmlns:r="http://schemas.openxmlformats.org/officeDocument/2006/relationships" xmlns:p="http://schemas.openxmlformats.org/presentationml/2006/main">
   <p:cSld>
     <p:spTree>
       <p:nvGrpSpPr>
@@ -850,7 +866,7 @@
             <a:spLocks noGrp="1"/>
           </p:cNvSpPr>
           <p:nvPr>
-            <p:ph type="body" idx="3" sz="quarter"/>
+            <p:ph type="body" sz="quarter" idx="3"/>
           </p:nvPr>
         </p:nvSpPr>
         <p:spPr/>
@@ -859,7 +875,7 @@
           <a:lstStyle/>
           <a:p>
             <a:r>
-              <a:t>不要解释什么是 RAG，不要出现英文缩写。只讲一件事：估时必须有依据，而且这个依据可以复算。305 / 375 / 461 是真实的测试输出。</a:t>
+              <a:t>这一页要讲得坦诚。失败不会让项目显得不完整，能解释失败并且改掉才说明工程能力。最后那条边界一定要说，不要跳过。</a:t>
             </a:r>
           </a:p>
         </p:txBody>
@@ -871,7 +887,7 @@
             <a:spLocks noGrp="1"/>
           </p:cNvSpPr>
           <p:nvPr>
-            <p:ph type="sldNum" idx="5" sz="quarter"/>
+            <p:ph type="sldNum" sz="quarter" idx="5"/>
           </p:nvPr>
         </p:nvSpPr>
         <p:spPr/>
@@ -885,7 +901,7 @@
 </file>
 
 <file path=ppt/notesSlides/notesSlide7.xml><?xml version="1.0" encoding="utf-8"?>
-<p:notes xmlns:a="http://schemas.openxmlformats.org/drawingml/2006/main" xmlns:p="http://schemas.openxmlformats.org/presentationml/2006/main" xmlns:r="http://schemas.openxmlformats.org/officeDocument/2006/relationships">
+<p:notes xmlns:a="http://schemas.openxmlformats.org/drawingml/2006/main" xmlns:r="http://schemas.openxmlformats.org/officeDocument/2006/relationships" xmlns:p="http://schemas.openxmlformats.org/presentationml/2006/main">
   <p:cSld>
     <p:spTree>
       <p:nvGrpSpPr>
@@ -920,7 +936,7 @@
             <a:spLocks noGrp="1"/>
           </p:cNvSpPr>
           <p:nvPr>
-            <p:ph type="body" idx="3" sz="quarter"/>
+            <p:ph type="body" sz="quarter" idx="3"/>
           </p:nvPr>
         </p:nvSpPr>
         <p:spPr/>
@@ -929,7 +945,7 @@
           <a:lstStyle/>
           <a:p>
             <a:r>
-              <a:t>这一页要讲得坦诚。失败不会让项目显得不完整，能解释失败并且改掉才说明工程能力。最后那条边界一定要说，不要跳过。</a:t>
+              <a:t>不要解释什么是 RAG，不要出现英文缩写。只讲一件事：估时必须有依据，而且这个依据可以复算。305 / 375 / 461 是真实的测试输出。</a:t>
             </a:r>
           </a:p>
         </p:txBody>
@@ -941,7 +957,7 @@
             <a:spLocks noGrp="1"/>
           </p:cNvSpPr>
           <p:nvPr>
-            <p:ph type="sldNum" idx="5" sz="quarter"/>
+            <p:ph type="sldNum" sz="quarter" idx="5"/>
           </p:nvPr>
         </p:nvSpPr>
         <p:spPr/>
@@ -955,7 +971,7 @@
 </file>
 
 <file path=ppt/notesSlides/notesSlide8.xml><?xml version="1.0" encoding="utf-8"?>
-<p:notes xmlns:a="http://schemas.openxmlformats.org/drawingml/2006/main" xmlns:p="http://schemas.openxmlformats.org/presentationml/2006/main" xmlns:r="http://schemas.openxmlformats.org/officeDocument/2006/relationships">
+<p:notes xmlns:a="http://schemas.openxmlformats.org/drawingml/2006/main" xmlns:r="http://schemas.openxmlformats.org/officeDocument/2006/relationships" xmlns:p="http://schemas.openxmlformats.org/presentationml/2006/main">
   <p:cSld>
     <p:spTree>
       <p:nvGrpSpPr>
@@ -990,7 +1006,7 @@
             <a:spLocks noGrp="1"/>
           </p:cNvSpPr>
           <p:nvPr>
-            <p:ph type="body" idx="3" sz="quarter"/>
+            <p:ph type="body" sz="quarter" idx="3"/>
           </p:nvPr>
         </p:nvSpPr>
         <p:spPr/>
@@ -1011,7 +1027,7 @@
             <a:spLocks noGrp="1"/>
           </p:cNvSpPr>
           <p:nvPr>
-            <p:ph type="sldNum" idx="5" sz="quarter"/>
+            <p:ph type="sldNum" sz="quarter" idx="5"/>
           </p:nvPr>
         </p:nvSpPr>
         <p:spPr/>
@@ -1205,7 +1221,6 @@
           <a:p>
             <a:fld id="{5BCAD085-E8A6-8845-BD4E-CB4CCA059FC4}" type="datetimeFigureOut">
               <a:rPr lang="en-US" smtClean="0"/>
-              <a:t>1/27/13</a:t>
             </a:fld>
             <a:endParaRPr lang="en-US"/>
           </a:p>
@@ -1247,18 +1262,12 @@
           <a:p>
             <a:fld id="{C1FF6DA9-008F-8B48-92A6-B652298478BF}" type="slidenum">
               <a:rPr lang="en-US" smtClean="0"/>
-              <a:t>‹#›</a:t>
             </a:fld>
             <a:endParaRPr lang="en-US"/>
           </a:p>
         </p:txBody>
       </p:sp>
     </p:spTree>
-    <p:extLst>
-      <p:ext uri="{BB962C8B-B14F-4D97-AF65-F5344CB8AC3E}">
-        <p14:creationId xmlns:p14="http://schemas.microsoft.com/office/powerpoint/2010/main" val="3168075583"/>
-      </p:ext>
-    </p:extLst>
   </p:cSld>
   <p:clrMapOvr>
     <a:masterClrMapping/>
@@ -1326,6 +1335,7 @@
               <a:rPr lang="en-US" smtClean="0"/>
               <a:t>Click to edit Master text styles</a:t>
             </a:r>
+            <a:endParaRPr lang="en-US" smtClean="0"/>
           </a:p>
           <a:p>
             <a:pPr lvl="1"/>
@@ -1333,6 +1343,7 @@
               <a:rPr lang="en-US" smtClean="0"/>
               <a:t>Second level</a:t>
             </a:r>
+            <a:endParaRPr lang="en-US" smtClean="0"/>
           </a:p>
           <a:p>
             <a:pPr lvl="2"/>
@@ -1340,6 +1351,7 @@
               <a:rPr lang="en-US" smtClean="0"/>
               <a:t>Third level</a:t>
             </a:r>
+            <a:endParaRPr lang="en-US" smtClean="0"/>
           </a:p>
           <a:p>
             <a:pPr lvl="3"/>
@@ -1347,6 +1359,7 @@
               <a:rPr lang="en-US" smtClean="0"/>
               <a:t>Fourth level</a:t>
             </a:r>
+            <a:endParaRPr lang="en-US" smtClean="0"/>
           </a:p>
           <a:p>
             <a:pPr lvl="4"/>
@@ -1375,7 +1388,6 @@
           <a:p>
             <a:fld id="{5BCAD085-E8A6-8845-BD4E-CB4CCA059FC4}" type="datetimeFigureOut">
               <a:rPr lang="en-US" smtClean="0"/>
-              <a:t>1/27/13</a:t>
             </a:fld>
             <a:endParaRPr lang="en-US"/>
           </a:p>
@@ -1417,18 +1429,12 @@
           <a:p>
             <a:fld id="{C1FF6DA9-008F-8B48-92A6-B652298478BF}" type="slidenum">
               <a:rPr lang="en-US" smtClean="0"/>
-              <a:t>‹#›</a:t>
             </a:fld>
             <a:endParaRPr lang="en-US"/>
           </a:p>
         </p:txBody>
       </p:sp>
     </p:spTree>
-    <p:extLst>
-      <p:ext uri="{BB962C8B-B14F-4D97-AF65-F5344CB8AC3E}">
-        <p14:creationId xmlns:p14="http://schemas.microsoft.com/office/powerpoint/2010/main" val="2910927964"/>
-      </p:ext>
-    </p:extLst>
   </p:cSld>
   <p:clrMapOvr>
     <a:masterClrMapping/>
@@ -1506,6 +1512,7 @@
               <a:rPr lang="en-US" smtClean="0"/>
               <a:t>Click to edit Master text styles</a:t>
             </a:r>
+            <a:endParaRPr lang="en-US" smtClean="0"/>
           </a:p>
           <a:p>
             <a:pPr lvl="1"/>
@@ -1513,6 +1520,7 @@
               <a:rPr lang="en-US" smtClean="0"/>
               <a:t>Second level</a:t>
             </a:r>
+            <a:endParaRPr lang="en-US" smtClean="0"/>
           </a:p>
           <a:p>
             <a:pPr lvl="2"/>
@@ -1520,6 +1528,7 @@
               <a:rPr lang="en-US" smtClean="0"/>
               <a:t>Third level</a:t>
             </a:r>
+            <a:endParaRPr lang="en-US" smtClean="0"/>
           </a:p>
           <a:p>
             <a:pPr lvl="3"/>
@@ -1527,6 +1536,7 @@
               <a:rPr lang="en-US" smtClean="0"/>
               <a:t>Fourth level</a:t>
             </a:r>
+            <a:endParaRPr lang="en-US" smtClean="0"/>
           </a:p>
           <a:p>
             <a:pPr lvl="4"/>
@@ -1555,7 +1565,6 @@
           <a:p>
             <a:fld id="{5BCAD085-E8A6-8845-BD4E-CB4CCA059FC4}" type="datetimeFigureOut">
               <a:rPr lang="en-US" smtClean="0"/>
-              <a:t>1/27/13</a:t>
             </a:fld>
             <a:endParaRPr lang="en-US"/>
           </a:p>
@@ -1597,18 +1606,12 @@
           <a:p>
             <a:fld id="{C1FF6DA9-008F-8B48-92A6-B652298478BF}" type="slidenum">
               <a:rPr lang="en-US" smtClean="0"/>
-              <a:t>‹#›</a:t>
             </a:fld>
             <a:endParaRPr lang="en-US"/>
           </a:p>
         </p:txBody>
       </p:sp>
     </p:spTree>
-    <p:extLst>
-      <p:ext uri="{BB962C8B-B14F-4D97-AF65-F5344CB8AC3E}">
-        <p14:creationId xmlns:p14="http://schemas.microsoft.com/office/powerpoint/2010/main" val="3612223792"/>
-      </p:ext>
-    </p:extLst>
   </p:cSld>
   <p:clrMapOvr>
     <a:masterClrMapping/>
@@ -1676,6 +1679,7 @@
               <a:rPr lang="en-US" smtClean="0"/>
               <a:t>Click to edit Master text styles</a:t>
             </a:r>
+            <a:endParaRPr lang="en-US" smtClean="0"/>
           </a:p>
           <a:p>
             <a:pPr lvl="1"/>
@@ -1683,6 +1687,7 @@
               <a:rPr lang="en-US" smtClean="0"/>
               <a:t>Second level</a:t>
             </a:r>
+            <a:endParaRPr lang="en-US" smtClean="0"/>
           </a:p>
           <a:p>
             <a:pPr lvl="2"/>
@@ -1690,6 +1695,7 @@
               <a:rPr lang="en-US" smtClean="0"/>
               <a:t>Third level</a:t>
             </a:r>
+            <a:endParaRPr lang="en-US" smtClean="0"/>
           </a:p>
           <a:p>
             <a:pPr lvl="3"/>
@@ -1697,6 +1703,7 @@
               <a:rPr lang="en-US" smtClean="0"/>
               <a:t>Fourth level</a:t>
             </a:r>
+            <a:endParaRPr lang="en-US" smtClean="0"/>
           </a:p>
           <a:p>
             <a:pPr lvl="4"/>
@@ -1725,7 +1732,6 @@
           <a:p>
             <a:fld id="{5BCAD085-E8A6-8845-BD4E-CB4CCA059FC4}" type="datetimeFigureOut">
               <a:rPr lang="en-US" smtClean="0"/>
-              <a:t>1/27/13</a:t>
             </a:fld>
             <a:endParaRPr lang="en-US"/>
           </a:p>
@@ -1767,18 +1773,12 @@
           <a:p>
             <a:fld id="{C1FF6DA9-008F-8B48-92A6-B652298478BF}" type="slidenum">
               <a:rPr lang="en-US" smtClean="0"/>
-              <a:t>‹#›</a:t>
             </a:fld>
             <a:endParaRPr lang="en-US"/>
           </a:p>
         </p:txBody>
       </p:sp>
     </p:spTree>
-    <p:extLst>
-      <p:ext uri="{BB962C8B-B14F-4D97-AF65-F5344CB8AC3E}">
-        <p14:creationId xmlns:p14="http://schemas.microsoft.com/office/powerpoint/2010/main" val="2614314258"/>
-      </p:ext>
-    </p:extLst>
   </p:cSld>
   <p:clrMapOvr>
     <a:masterClrMapping/>
@@ -1951,6 +1951,7 @@
               <a:rPr lang="en-US" smtClean="0"/>
               <a:t>Click to edit Master text styles</a:t>
             </a:r>
+            <a:endParaRPr lang="en-US" smtClean="0"/>
           </a:p>
         </p:txBody>
       </p:sp>
@@ -1971,7 +1972,6 @@
           <a:p>
             <a:fld id="{5BCAD085-E8A6-8845-BD4E-CB4CCA059FC4}" type="datetimeFigureOut">
               <a:rPr lang="en-US" smtClean="0"/>
-              <a:t>1/27/13</a:t>
             </a:fld>
             <a:endParaRPr lang="en-US"/>
           </a:p>
@@ -2013,18 +2013,12 @@
           <a:p>
             <a:fld id="{C1FF6DA9-008F-8B48-92A6-B652298478BF}" type="slidenum">
               <a:rPr lang="en-US" smtClean="0"/>
-              <a:t>‹#›</a:t>
             </a:fld>
             <a:endParaRPr lang="en-US"/>
           </a:p>
         </p:txBody>
       </p:sp>
     </p:spTree>
-    <p:extLst>
-      <p:ext uri="{BB962C8B-B14F-4D97-AF65-F5344CB8AC3E}">
-        <p14:creationId xmlns:p14="http://schemas.microsoft.com/office/powerpoint/2010/main" val="960648375"/>
-      </p:ext>
-    </p:extLst>
   </p:cSld>
   <p:clrMapOvr>
     <a:masterClrMapping/>
@@ -2125,6 +2119,7 @@
               <a:rPr lang="en-US" smtClean="0"/>
               <a:t>Click to edit Master text styles</a:t>
             </a:r>
+            <a:endParaRPr lang="en-US" smtClean="0"/>
           </a:p>
           <a:p>
             <a:pPr lvl="1"/>
@@ -2132,6 +2127,7 @@
               <a:rPr lang="en-US" smtClean="0"/>
               <a:t>Second level</a:t>
             </a:r>
+            <a:endParaRPr lang="en-US" smtClean="0"/>
           </a:p>
           <a:p>
             <a:pPr lvl="2"/>
@@ -2139,6 +2135,7 @@
               <a:rPr lang="en-US" smtClean="0"/>
               <a:t>Third level</a:t>
             </a:r>
+            <a:endParaRPr lang="en-US" smtClean="0"/>
           </a:p>
           <a:p>
             <a:pPr lvl="3"/>
@@ -2146,6 +2143,7 @@
               <a:rPr lang="en-US" smtClean="0"/>
               <a:t>Fourth level</a:t>
             </a:r>
+            <a:endParaRPr lang="en-US" smtClean="0"/>
           </a:p>
           <a:p>
             <a:pPr lvl="4"/>
@@ -2210,6 +2208,7 @@
               <a:rPr lang="en-US" smtClean="0"/>
               <a:t>Click to edit Master text styles</a:t>
             </a:r>
+            <a:endParaRPr lang="en-US" smtClean="0"/>
           </a:p>
           <a:p>
             <a:pPr lvl="1"/>
@@ -2217,6 +2216,7 @@
               <a:rPr lang="en-US" smtClean="0"/>
               <a:t>Second level</a:t>
             </a:r>
+            <a:endParaRPr lang="en-US" smtClean="0"/>
           </a:p>
           <a:p>
             <a:pPr lvl="2"/>
@@ -2224,6 +2224,7 @@
               <a:rPr lang="en-US" smtClean="0"/>
               <a:t>Third level</a:t>
             </a:r>
+            <a:endParaRPr lang="en-US" smtClean="0"/>
           </a:p>
           <a:p>
             <a:pPr lvl="3"/>
@@ -2231,6 +2232,7 @@
               <a:rPr lang="en-US" smtClean="0"/>
               <a:t>Fourth level</a:t>
             </a:r>
+            <a:endParaRPr lang="en-US" smtClean="0"/>
           </a:p>
           <a:p>
             <a:pPr lvl="4"/>
@@ -2259,7 +2261,6 @@
           <a:p>
             <a:fld id="{5BCAD085-E8A6-8845-BD4E-CB4CCA059FC4}" type="datetimeFigureOut">
               <a:rPr lang="en-US" smtClean="0"/>
-              <a:t>1/27/13</a:t>
             </a:fld>
             <a:endParaRPr lang="en-US"/>
           </a:p>
@@ -2301,18 +2302,12 @@
           <a:p>
             <a:fld id="{C1FF6DA9-008F-8B48-92A6-B652298478BF}" type="slidenum">
               <a:rPr lang="en-US" smtClean="0"/>
-              <a:t>‹#›</a:t>
             </a:fld>
             <a:endParaRPr lang="en-US"/>
           </a:p>
         </p:txBody>
       </p:sp>
     </p:spTree>
-    <p:extLst>
-      <p:ext uri="{BB962C8B-B14F-4D97-AF65-F5344CB8AC3E}">
-        <p14:creationId xmlns:p14="http://schemas.microsoft.com/office/powerpoint/2010/main" val="2782244947"/>
-      </p:ext>
-    </p:extLst>
   </p:cSld>
   <p:clrMapOvr>
     <a:masterClrMapping/>
@@ -2426,6 +2421,7 @@
               <a:rPr lang="en-US" smtClean="0"/>
               <a:t>Click to edit Master text styles</a:t>
             </a:r>
+            <a:endParaRPr lang="en-US" smtClean="0"/>
           </a:p>
         </p:txBody>
       </p:sp>
@@ -2482,6 +2478,7 @@
               <a:rPr lang="en-US" smtClean="0"/>
               <a:t>Click to edit Master text styles</a:t>
             </a:r>
+            <a:endParaRPr lang="en-US" smtClean="0"/>
           </a:p>
           <a:p>
             <a:pPr lvl="1"/>
@@ -2489,6 +2486,7 @@
               <a:rPr lang="en-US" smtClean="0"/>
               <a:t>Second level</a:t>
             </a:r>
+            <a:endParaRPr lang="en-US" smtClean="0"/>
           </a:p>
           <a:p>
             <a:pPr lvl="2"/>
@@ -2496,6 +2494,7 @@
               <a:rPr lang="en-US" smtClean="0"/>
               <a:t>Third level</a:t>
             </a:r>
+            <a:endParaRPr lang="en-US" smtClean="0"/>
           </a:p>
           <a:p>
             <a:pPr lvl="3"/>
@@ -2503,6 +2502,7 @@
               <a:rPr lang="en-US" smtClean="0"/>
               <a:t>Fourth level</a:t>
             </a:r>
+            <a:endParaRPr lang="en-US" smtClean="0"/>
           </a:p>
           <a:p>
             <a:pPr lvl="4"/>
@@ -2576,6 +2576,7 @@
               <a:rPr lang="en-US" smtClean="0"/>
               <a:t>Click to edit Master text styles</a:t>
             </a:r>
+            <a:endParaRPr lang="en-US" smtClean="0"/>
           </a:p>
         </p:txBody>
       </p:sp>
@@ -2632,6 +2633,7 @@
               <a:rPr lang="en-US" smtClean="0"/>
               <a:t>Click to edit Master text styles</a:t>
             </a:r>
+            <a:endParaRPr lang="en-US" smtClean="0"/>
           </a:p>
           <a:p>
             <a:pPr lvl="1"/>
@@ -2639,6 +2641,7 @@
               <a:rPr lang="en-US" smtClean="0"/>
               <a:t>Second level</a:t>
             </a:r>
+            <a:endParaRPr lang="en-US" smtClean="0"/>
           </a:p>
           <a:p>
             <a:pPr lvl="2"/>
@@ -2646,6 +2649,7 @@
               <a:rPr lang="en-US" smtClean="0"/>
               <a:t>Third level</a:t>
             </a:r>
+            <a:endParaRPr lang="en-US" smtClean="0"/>
           </a:p>
           <a:p>
             <a:pPr lvl="3"/>
@@ -2653,6 +2657,7 @@
               <a:rPr lang="en-US" smtClean="0"/>
               <a:t>Fourth level</a:t>
             </a:r>
+            <a:endParaRPr lang="en-US" smtClean="0"/>
           </a:p>
           <a:p>
             <a:pPr lvl="4"/>
@@ -2681,7 +2686,6 @@
           <a:p>
             <a:fld id="{5BCAD085-E8A6-8845-BD4E-CB4CCA059FC4}" type="datetimeFigureOut">
               <a:rPr lang="en-US" smtClean="0"/>
-              <a:t>1/27/13</a:t>
             </a:fld>
             <a:endParaRPr lang="en-US"/>
           </a:p>
@@ -2723,18 +2727,12 @@
           <a:p>
             <a:fld id="{C1FF6DA9-008F-8B48-92A6-B652298478BF}" type="slidenum">
               <a:rPr lang="en-US" smtClean="0"/>
-              <a:t>‹#›</a:t>
             </a:fld>
             <a:endParaRPr lang="en-US"/>
           </a:p>
         </p:txBody>
       </p:sp>
     </p:spTree>
-    <p:extLst>
-      <p:ext uri="{BB962C8B-B14F-4D97-AF65-F5344CB8AC3E}">
-        <p14:creationId xmlns:p14="http://schemas.microsoft.com/office/powerpoint/2010/main" val="990158736"/>
-      </p:ext>
-    </p:extLst>
   </p:cSld>
   <p:clrMapOvr>
     <a:masterClrMapping/>
@@ -2799,7 +2797,6 @@
           <a:p>
             <a:fld id="{5BCAD085-E8A6-8845-BD4E-CB4CCA059FC4}" type="datetimeFigureOut">
               <a:rPr lang="en-US" smtClean="0"/>
-              <a:t>1/27/13</a:t>
             </a:fld>
             <a:endParaRPr lang="en-US"/>
           </a:p>
@@ -2841,18 +2838,12 @@
           <a:p>
             <a:fld id="{C1FF6DA9-008F-8B48-92A6-B652298478BF}" type="slidenum">
               <a:rPr lang="en-US" smtClean="0"/>
-              <a:t>‹#›</a:t>
             </a:fld>
             <a:endParaRPr lang="en-US"/>
           </a:p>
         </p:txBody>
       </p:sp>
     </p:spTree>
-    <p:extLst>
-      <p:ext uri="{BB962C8B-B14F-4D97-AF65-F5344CB8AC3E}">
-        <p14:creationId xmlns:p14="http://schemas.microsoft.com/office/powerpoint/2010/main" val="727027711"/>
-      </p:ext>
-    </p:extLst>
   </p:cSld>
   <p:clrMapOvr>
     <a:masterClrMapping/>
@@ -2894,7 +2885,6 @@
           <a:p>
             <a:fld id="{5BCAD085-E8A6-8845-BD4E-CB4CCA059FC4}" type="datetimeFigureOut">
               <a:rPr lang="en-US" smtClean="0"/>
-              <a:t>1/27/13</a:t>
             </a:fld>
             <a:endParaRPr lang="en-US"/>
           </a:p>
@@ -2936,18 +2926,12 @@
           <a:p>
             <a:fld id="{C1FF6DA9-008F-8B48-92A6-B652298478BF}" type="slidenum">
               <a:rPr lang="en-US" smtClean="0"/>
-              <a:t>‹#›</a:t>
             </a:fld>
             <a:endParaRPr lang="en-US"/>
           </a:p>
         </p:txBody>
       </p:sp>
     </p:spTree>
-    <p:extLst>
-      <p:ext uri="{BB962C8B-B14F-4D97-AF65-F5344CB8AC3E}">
-        <p14:creationId xmlns:p14="http://schemas.microsoft.com/office/powerpoint/2010/main" val="1212999818"/>
-      </p:ext>
-    </p:extLst>
   </p:cSld>
   <p:clrMapOvr>
     <a:masterClrMapping/>
@@ -3057,6 +3041,7 @@
               <a:rPr lang="en-US" smtClean="0"/>
               <a:t>Click to edit Master text styles</a:t>
             </a:r>
+            <a:endParaRPr lang="en-US" smtClean="0"/>
           </a:p>
           <a:p>
             <a:pPr lvl="1"/>
@@ -3064,6 +3049,7 @@
               <a:rPr lang="en-US" smtClean="0"/>
               <a:t>Second level</a:t>
             </a:r>
+            <a:endParaRPr lang="en-US" smtClean="0"/>
           </a:p>
           <a:p>
             <a:pPr lvl="2"/>
@@ -3071,6 +3057,7 @@
               <a:rPr lang="en-US" smtClean="0"/>
               <a:t>Third level</a:t>
             </a:r>
+            <a:endParaRPr lang="en-US" smtClean="0"/>
           </a:p>
           <a:p>
             <a:pPr lvl="3"/>
@@ -3078,6 +3065,7 @@
               <a:rPr lang="en-US" smtClean="0"/>
               <a:t>Fourth level</a:t>
             </a:r>
+            <a:endParaRPr lang="en-US" smtClean="0"/>
           </a:p>
           <a:p>
             <a:pPr lvl="4"/>
@@ -3151,6 +3139,7 @@
               <a:rPr lang="en-US" smtClean="0"/>
               <a:t>Click to edit Master text styles</a:t>
             </a:r>
+            <a:endParaRPr lang="en-US" smtClean="0"/>
           </a:p>
         </p:txBody>
       </p:sp>
@@ -3171,7 +3160,6 @@
           <a:p>
             <a:fld id="{5BCAD085-E8A6-8845-BD4E-CB4CCA059FC4}" type="datetimeFigureOut">
               <a:rPr lang="en-US" smtClean="0"/>
-              <a:t>1/27/13</a:t>
             </a:fld>
             <a:endParaRPr lang="en-US"/>
           </a:p>
@@ -3213,18 +3201,12 @@
           <a:p>
             <a:fld id="{C1FF6DA9-008F-8B48-92A6-B652298478BF}" type="slidenum">
               <a:rPr lang="en-US" smtClean="0"/>
-              <a:t>‹#›</a:t>
             </a:fld>
             <a:endParaRPr lang="en-US"/>
           </a:p>
         </p:txBody>
       </p:sp>
     </p:spTree>
-    <p:extLst>
-      <p:ext uri="{BB962C8B-B14F-4D97-AF65-F5344CB8AC3E}">
-        <p14:creationId xmlns:p14="http://schemas.microsoft.com/office/powerpoint/2010/main" val="1840726560"/>
-      </p:ext>
-    </p:extLst>
   </p:cSld>
   <p:clrMapOvr>
     <a:masterClrMapping/>
@@ -3404,6 +3386,7 @@
               <a:rPr lang="en-US" smtClean="0"/>
               <a:t>Click to edit Master text styles</a:t>
             </a:r>
+            <a:endParaRPr lang="en-US" smtClean="0"/>
           </a:p>
         </p:txBody>
       </p:sp>
@@ -3424,7 +3407,6 @@
           <a:p>
             <a:fld id="{5BCAD085-E8A6-8845-BD4E-CB4CCA059FC4}" type="datetimeFigureOut">
               <a:rPr lang="en-US" smtClean="0"/>
-              <a:t>1/27/13</a:t>
             </a:fld>
             <a:endParaRPr lang="en-US"/>
           </a:p>
@@ -3466,18 +3448,12 @@
           <a:p>
             <a:fld id="{C1FF6DA9-008F-8B48-92A6-B652298478BF}" type="slidenum">
               <a:rPr lang="en-US" smtClean="0"/>
-              <a:t>‹#›</a:t>
             </a:fld>
             <a:endParaRPr lang="en-US"/>
           </a:p>
         </p:txBody>
       </p:sp>
     </p:spTree>
-    <p:extLst>
-      <p:ext uri="{BB962C8B-B14F-4D97-AF65-F5344CB8AC3E}">
-        <p14:creationId xmlns:p14="http://schemas.microsoft.com/office/powerpoint/2010/main" val="3889236939"/>
-      </p:ext>
-    </p:extLst>
   </p:cSld>
   <p:clrMapOvr>
     <a:masterClrMapping/>
@@ -3570,6 +3546,7 @@
               <a:rPr lang="en-US" smtClean="0"/>
               <a:t>Click to edit Master text styles</a:t>
             </a:r>
+            <a:endParaRPr lang="en-US" smtClean="0"/>
           </a:p>
           <a:p>
             <a:pPr lvl="1"/>
@@ -3577,6 +3554,7 @@
               <a:rPr lang="en-US" smtClean="0"/>
               <a:t>Second level</a:t>
             </a:r>
+            <a:endParaRPr lang="en-US" smtClean="0"/>
           </a:p>
           <a:p>
             <a:pPr lvl="2"/>
@@ -3584,6 +3562,7 @@
               <a:rPr lang="en-US" smtClean="0"/>
               <a:t>Third level</a:t>
             </a:r>
+            <a:endParaRPr lang="en-US" smtClean="0"/>
           </a:p>
           <a:p>
             <a:pPr lvl="3"/>
@@ -3591,6 +3570,7 @@
               <a:rPr lang="en-US" smtClean="0"/>
               <a:t>Fourth level</a:t>
             </a:r>
+            <a:endParaRPr lang="en-US" smtClean="0"/>
           </a:p>
           <a:p>
             <a:pPr lvl="4"/>
@@ -3637,7 +3617,6 @@
           <a:p>
             <a:fld id="{5BCAD085-E8A6-8845-BD4E-CB4CCA059FC4}" type="datetimeFigureOut">
               <a:rPr lang="en-US" smtClean="0"/>
-              <a:t>1/27/13</a:t>
             </a:fld>
             <a:endParaRPr lang="en-US"/>
           </a:p>
@@ -3715,18 +3694,12 @@
           <a:p>
             <a:fld id="{C1FF6DA9-008F-8B48-92A6-B652298478BF}" type="slidenum">
               <a:rPr lang="en-US" smtClean="0"/>
-              <a:t>‹#›</a:t>
             </a:fld>
             <a:endParaRPr lang="en-US"/>
           </a:p>
         </p:txBody>
       </p:sp>
     </p:spTree>
-    <p:extLst>
-      <p:ext uri="{BB962C8B-B14F-4D97-AF65-F5344CB8AC3E}">
-        <p14:creationId xmlns:p14="http://schemas.microsoft.com/office/powerpoint/2010/main" val="2209977519"/>
-      </p:ext>
-    </p:extLst>
   </p:cSld>
   <p:clrMap bg1="lt1" tx1="dk1" bg2="lt2" tx2="dk2" accent1="accent1" accent2="accent2" accent3="accent3" accent4="accent4" accent5="accent5" accent6="accent6" hlink="hlink" folHlink="folHlink"/>
   <p:sldLayoutIdLst>
@@ -3764,7 +3737,7 @@
         <a:spcBef>
           <a:spcPct val="20000"/>
         </a:spcBef>
-        <a:buFont typeface="Arial"/>
+        <a:buFont typeface="Arial" panose="020B0604020202090204"/>
         <a:buChar char="•"/>
         <a:defRPr sz="3200" kern="1200">
           <a:solidFill>
@@ -3779,7 +3752,7 @@
         <a:spcBef>
           <a:spcPct val="20000"/>
         </a:spcBef>
-        <a:buFont typeface="Arial"/>
+        <a:buFont typeface="Arial" panose="020B0604020202090204"/>
         <a:buChar char="–"/>
         <a:defRPr sz="2800" kern="1200">
           <a:solidFill>
@@ -3794,7 +3767,7 @@
         <a:spcBef>
           <a:spcPct val="20000"/>
         </a:spcBef>
-        <a:buFont typeface="Arial"/>
+        <a:buFont typeface="Arial" panose="020B0604020202090204"/>
         <a:buChar char="•"/>
         <a:defRPr sz="2400" kern="1200">
           <a:solidFill>
@@ -3809,7 +3782,7 @@
         <a:spcBef>
           <a:spcPct val="20000"/>
         </a:spcBef>
-        <a:buFont typeface="Arial"/>
+        <a:buFont typeface="Arial" panose="020B0604020202090204"/>
         <a:buChar char="–"/>
         <a:defRPr sz="2000" kern="1200">
           <a:solidFill>
@@ -3824,7 +3797,7 @@
         <a:spcBef>
           <a:spcPct val="20000"/>
         </a:spcBef>
-        <a:buFont typeface="Arial"/>
+        <a:buFont typeface="Arial" panose="020B0604020202090204"/>
         <a:buChar char="»"/>
         <a:defRPr sz="2000" kern="1200">
           <a:solidFill>
@@ -3839,7 +3812,7 @@
         <a:spcBef>
           <a:spcPct val="20000"/>
         </a:spcBef>
-        <a:buFont typeface="Arial"/>
+        <a:buFont typeface="Arial" panose="020B0604020202090204"/>
         <a:buChar char="•"/>
         <a:defRPr sz="2000" kern="1200">
           <a:solidFill>
@@ -3854,7 +3827,7 @@
         <a:spcBef>
           <a:spcPct val="20000"/>
         </a:spcBef>
-        <a:buFont typeface="Arial"/>
+        <a:buFont typeface="Arial" panose="020B0604020202090204"/>
         <a:buChar char="•"/>
         <a:defRPr sz="2000" kern="1200">
           <a:solidFill>
@@ -3869,7 +3842,7 @@
         <a:spcBef>
           <a:spcPct val="20000"/>
         </a:spcBef>
-        <a:buFont typeface="Arial"/>
+        <a:buFont typeface="Arial" panose="020B0604020202090204"/>
         <a:buChar char="•"/>
         <a:defRPr sz="2000" kern="1200">
           <a:solidFill>
@@ -3884,7 +3857,7 @@
         <a:spcBef>
           <a:spcPct val="20000"/>
         </a:spcBef>
-        <a:buFont typeface="Arial"/>
+        <a:buFont typeface="Arial" panose="020B0604020202090204"/>
         <a:buChar char="•"/>
         <a:defRPr sz="2000" kern="1200">
           <a:solidFill>
@@ -3996,7 +3969,7 @@
 </file>
 
 <file path=ppt/slides/slide1.xml><?xml version="1.0" encoding="utf-8"?>
-<p:sld xmlns:a="http://schemas.openxmlformats.org/drawingml/2006/main" xmlns:p="http://schemas.openxmlformats.org/presentationml/2006/main" xmlns:r="http://schemas.openxmlformats.org/officeDocument/2006/relationships">
+<p:sld xmlns:a="http://schemas.openxmlformats.org/drawingml/2006/main" xmlns:r="http://schemas.openxmlformats.org/officeDocument/2006/relationships" xmlns:p="http://schemas.openxmlformats.org/presentationml/2006/main">
   <p:cSld>
     <p:spTree>
       <p:nvGrpSpPr>
@@ -4028,7 +4001,7 @@
                 <a:srgbClr val="F7F2E0"/>
               </a:gs>
             </a:gsLst>
-            <a:lin scaled="0" ang="16200000"/>
+            <a:lin ang="16200000" scaled="0"/>
           </a:gradFill>
           <a:ln>
             <a:noFill/>
@@ -4103,10 +4076,16 @@
                 <a:solidFill>
                   <a:srgbClr val="FFFFFF"/>
                 </a:solidFill>
-                <a:latin typeface="PingFang SC"/>
+                <a:latin typeface="PingFang SC" panose="020B0400000000000000" charset="-122"/>
               </a:rPr>
               <a:t>2.0</a:t>
             </a:r>
+            <a:endParaRPr sz="2600" b="1">
+              <a:solidFill>
+                <a:srgbClr val="FFFFFF"/>
+              </a:solidFill>
+              <a:latin typeface="PingFang SC" panose="020B0400000000000000" charset="-122"/>
+            </a:endParaRPr>
           </a:p>
         </p:txBody>
       </p:sp>
@@ -4142,10 +4121,16 @@
                 <a:solidFill>
                   <a:srgbClr val="61707C"/>
                 </a:solidFill>
-                <a:latin typeface="PingFang SC"/>
+                <a:latin typeface="PingFang SC" panose="020B0400000000000000" charset="-122"/>
               </a:rPr>
               <a:t>《大模型工程》学生产品发布会</a:t>
             </a:r>
+            <a:endParaRPr sz="1700" b="0">
+              <a:solidFill>
+                <a:srgbClr val="61707C"/>
+              </a:solidFill>
+              <a:latin typeface="PingFang SC" panose="020B0400000000000000" charset="-122"/>
+            </a:endParaRPr>
           </a:p>
         </p:txBody>
       </p:sp>
@@ -4181,7 +4166,7 @@
                 <a:solidFill>
                   <a:srgbClr val="2E3A45"/>
                 </a:solidFill>
-                <a:latin typeface="PingFang SC"/>
+                <a:latin typeface="PingFang SC" panose="020B0400000000000000" charset="-122"/>
               </a:rPr>
               <a:t>J人模拟器 </a:t>
             </a:r>
@@ -4190,10 +4175,16 @@
                 <a:solidFill>
                   <a:srgbClr val="E8823C"/>
                 </a:solidFill>
-                <a:latin typeface="PingFang SC"/>
+                <a:latin typeface="PingFang SC" panose="020B0400000000000000" charset="-122"/>
               </a:rPr>
               <a:t>2.0</a:t>
             </a:r>
+            <a:endParaRPr sz="6000" b="1">
+              <a:solidFill>
+                <a:srgbClr val="E8823C"/>
+              </a:solidFill>
+              <a:latin typeface="PingFang SC" panose="020B0400000000000000" charset="-122"/>
+            </a:endParaRPr>
           </a:p>
         </p:txBody>
       </p:sp>
@@ -4229,10 +4220,16 @@
                 <a:solidFill>
                   <a:srgbClr val="61707C"/>
                 </a:solidFill>
-                <a:latin typeface="PingFang SC"/>
+                <a:latin typeface="PingFang SC" panose="020B0400000000000000" charset="-122"/>
               </a:rPr>
               <a:t>一句话，把学习任务排进你真实的空闲时间</a:t>
             </a:r>
+            <a:endParaRPr sz="2600" b="0">
+              <a:solidFill>
+                <a:srgbClr val="61707C"/>
+              </a:solidFill>
+              <a:latin typeface="PingFang SC" panose="020B0400000000000000" charset="-122"/>
+            </a:endParaRPr>
           </a:p>
         </p:txBody>
       </p:sp>
@@ -4245,7 +4242,7 @@
         <p:spPr>
           <a:xfrm>
             <a:off x="713232" y="5897880"/>
-            <a:ext cx="10765231" cy="457200"/>
+            <a:ext cx="10765231" cy="398780"/>
           </a:xfrm>
           <a:prstGeom prst="rect">
             <a:avLst/>
@@ -4268,10 +4265,16 @@
                 <a:solidFill>
                   <a:srgbClr val="61707C"/>
                 </a:solidFill>
-                <a:latin typeface="PingFang SC"/>
+                <a:latin typeface="PingFang SC" panose="020B0400000000000000" charset="-122"/>
               </a:rPr>
-              <a:t>刘知行 Ballie    ·    2026.08.29    ·    醋溜科技展示场地</a:t>
-            </a:r>
+              <a:t>刘知行 Ballie    ·    2026.08.29</a:t>
+            </a:r>
+            <a:endParaRPr sz="1600" b="0">
+              <a:solidFill>
+                <a:srgbClr val="61707C"/>
+              </a:solidFill>
+              <a:latin typeface="PingFang SC" panose="020B0400000000000000" charset="-122"/>
+            </a:endParaRPr>
           </a:p>
         </p:txBody>
       </p:sp>
@@ -4284,7 +4287,7 @@
 </file>
 
 <file path=ppt/slides/slide2.xml><?xml version="1.0" encoding="utf-8"?>
-<p:sld xmlns:a="http://schemas.openxmlformats.org/drawingml/2006/main" xmlns:p="http://schemas.openxmlformats.org/presentationml/2006/main" xmlns:r="http://schemas.openxmlformats.org/officeDocument/2006/relationships">
+<p:sld xmlns:a="http://schemas.openxmlformats.org/drawingml/2006/main" xmlns:r="http://schemas.openxmlformats.org/officeDocument/2006/relationships" xmlns:p="http://schemas.openxmlformats.org/presentationml/2006/main">
   <p:cSld>
     <p:spTree>
       <p:nvGrpSpPr>
@@ -4316,7 +4319,7 @@
                 <a:srgbClr val="F7F2E0"/>
               </a:gs>
             </a:gsLst>
-            <a:lin scaled="0" ang="16200000"/>
+            <a:lin ang="16200000" scaled="0"/>
           </a:gradFill>
           <a:ln>
             <a:noFill/>
@@ -4377,10 +4380,16 @@
                 <a:solidFill>
                   <a:srgbClr val="2E3A45"/>
                 </a:solidFill>
-                <a:latin typeface="PingFang SC"/>
+                <a:latin typeface="PingFang SC" panose="020B0400000000000000" charset="-122"/>
               </a:rPr>
               <a:t>1.0 已经能排计划了，但没人愿意用</a:t>
             </a:r>
+            <a:endParaRPr sz="4000" b="1">
+              <a:solidFill>
+                <a:srgbClr val="2E3A45"/>
+              </a:solidFill>
+              <a:latin typeface="PingFang SC" panose="020B0400000000000000" charset="-122"/>
+            </a:endParaRPr>
           </a:p>
         </p:txBody>
       </p:sp>
@@ -4425,7 +4434,7 @@
           </a:fontRef>
         </p:style>
         <p:txBody>
-          <a:bodyPr rtlCol="0" anchor="ctr" wrap="square" lIns="219456" rIns="219456" tIns="146304" bIns="146304"/>
+          <a:bodyPr wrap="square" lIns="219456" tIns="146304" rIns="219456" bIns="146304" rtlCol="0" anchor="ctr"/>
           <a:lstStyle/>
           <a:p>
             <a:pPr algn="ctr">
@@ -4438,10 +4447,16 @@
                 <a:solidFill>
                   <a:srgbClr val="61707C"/>
                 </a:solidFill>
-                <a:latin typeface="PingFang SC"/>
+                <a:latin typeface="PingFang SC" panose="020B0400000000000000" charset="-122"/>
               </a:rPr>
               <a:t>它确实是通的</a:t>
             </a:r>
+            <a:endParaRPr sz="1300" b="0">
+              <a:solidFill>
+                <a:srgbClr val="61707C"/>
+              </a:solidFill>
+              <a:latin typeface="PingFang SC" panose="020B0400000000000000" charset="-122"/>
+            </a:endParaRPr>
           </a:p>
           <a:p>
             <a:pPr>
@@ -4454,10 +4469,16 @@
                 <a:solidFill>
                   <a:srgbClr val="2E3A45"/>
                 </a:solidFill>
-                <a:latin typeface="PingFang SC"/>
+                <a:latin typeface="PingFang SC" panose="020B0400000000000000" charset="-122"/>
               </a:rPr>
               <a:t>录任务、设空闲、生成跨天时间轴，闭环已经跑起来了</a:t>
             </a:r>
+            <a:endParaRPr sz="2000" b="0">
+              <a:solidFill>
+                <a:srgbClr val="2E3A45"/>
+              </a:solidFill>
+              <a:latin typeface="PingFang SC" panose="020B0400000000000000" charset="-122"/>
+            </a:endParaRPr>
           </a:p>
         </p:txBody>
       </p:sp>
@@ -4502,7 +4523,7 @@
           </a:fontRef>
         </p:style>
         <p:txBody>
-          <a:bodyPr rtlCol="0" anchor="ctr" wrap="square" lIns="219456" rIns="219456" tIns="146304" bIns="146304"/>
+          <a:bodyPr wrap="square" lIns="219456" tIns="146304" rIns="219456" bIns="146304" rtlCol="0" anchor="ctr"/>
           <a:lstStyle/>
           <a:p>
             <a:pPr algn="ctr">
@@ -4515,10 +4536,16 @@
                 <a:solidFill>
                   <a:srgbClr val="61707C"/>
                 </a:solidFill>
-                <a:latin typeface="PingFang SC"/>
+                <a:latin typeface="PingFang SC" panose="020B0400000000000000" charset="-122"/>
               </a:rPr>
               <a:t>但录一个任务要点十下</a:t>
             </a:r>
+            <a:endParaRPr sz="1300" b="0">
+              <a:solidFill>
+                <a:srgbClr val="61707C"/>
+              </a:solidFill>
+              <a:latin typeface="PingFang SC" panose="020B0400000000000000" charset="-122"/>
+            </a:endParaRPr>
           </a:p>
           <a:p>
             <a:pPr>
@@ -4531,10 +4558,16 @@
                 <a:solidFill>
                   <a:srgbClr val="2E3A45"/>
                 </a:solidFill>
-                <a:latin typeface="PingFang SC"/>
+                <a:latin typeface="PingFang SC" panose="020B0400000000000000" charset="-122"/>
               </a:rPr>
               <a:t>得切到计划列表，一个字段一个字段填表</a:t>
             </a:r>
+            <a:endParaRPr sz="2000" b="0">
+              <a:solidFill>
+                <a:srgbClr val="2E3A45"/>
+              </a:solidFill>
+              <a:latin typeface="PingFang SC" panose="020B0400000000000000" charset="-122"/>
+            </a:endParaRPr>
           </a:p>
         </p:txBody>
       </p:sp>
@@ -4579,7 +4612,7 @@
           </a:fontRef>
         </p:style>
         <p:txBody>
-          <a:bodyPr rtlCol="0" anchor="ctr" wrap="square" lIns="219456" rIns="219456" tIns="146304" bIns="146304"/>
+          <a:bodyPr wrap="square" lIns="219456" tIns="146304" rIns="219456" bIns="146304" rtlCol="0" anchor="ctr"/>
           <a:lstStyle/>
           <a:p>
             <a:pPr algn="ctr">
@@ -4592,10 +4625,16 @@
                 <a:solidFill>
                   <a:srgbClr val="61707C"/>
                 </a:solidFill>
-                <a:latin typeface="PingFang SC"/>
+                <a:latin typeface="PingFang SC" panose="020B0400000000000000" charset="-122"/>
               </a:rPr>
               <a:t>而且慢</a:t>
             </a:r>
+            <a:endParaRPr sz="1300" b="0">
+              <a:solidFill>
+                <a:srgbClr val="61707C"/>
+              </a:solidFill>
+              <a:latin typeface="PingFang SC" panose="020B0400000000000000" charset="-122"/>
+            </a:endParaRPr>
           </a:p>
           <a:p>
             <a:pPr>
@@ -4608,7 +4647,7 @@
                 <a:solidFill>
                   <a:srgbClr val="2E3A45"/>
                 </a:solidFill>
-                <a:latin typeface="PingFang SC"/>
+                <a:latin typeface="PingFang SC" panose="020B0400000000000000" charset="-122"/>
               </a:rPr>
               <a:t>计划生成跑本地小模型 </a:t>
             </a:r>
@@ -4617,7 +4656,7 @@
                 <a:solidFill>
                   <a:srgbClr val="E8823C"/>
                 </a:solidFill>
-                <a:latin typeface="PingFang SC"/>
+                <a:latin typeface="PingFang SC" panose="020B0400000000000000" charset="-122"/>
               </a:rPr>
               <a:t>qwen3:0.6b</a:t>
             </a:r>
@@ -4626,10 +4665,16 @@
                 <a:solidFill>
                   <a:srgbClr val="2E3A45"/>
                 </a:solidFill>
-                <a:latin typeface="PingFang SC"/>
+                <a:latin typeface="PingFang SC" panose="020B0400000000000000" charset="-122"/>
               </a:rPr>
               <a:t>，经常吐不出能用的结果</a:t>
             </a:r>
+            <a:endParaRPr sz="2000" b="0">
+              <a:solidFill>
+                <a:srgbClr val="2E3A45"/>
+              </a:solidFill>
+              <a:latin typeface="PingFang SC" panose="020B0400000000000000" charset="-122"/>
+            </a:endParaRPr>
           </a:p>
         </p:txBody>
       </p:sp>
@@ -4714,7 +4759,7 @@
           </a:fontRef>
         </p:style>
         <p:txBody>
-          <a:bodyPr rtlCol="0" anchor="ctr" wrap="square" lIns="256032"/>
+          <a:bodyPr wrap="square" lIns="256032" rtlCol="0" anchor="ctr"/>
           <a:lstStyle/>
           <a:p>
             <a:pPr algn="ctr"/>
@@ -4723,10 +4768,16 @@
                 <a:solidFill>
                   <a:srgbClr val="2E3A45"/>
                 </a:solidFill>
-                <a:latin typeface="PingFang SC"/>
+                <a:latin typeface="PingFang SC" panose="020B0400000000000000" charset="-122"/>
               </a:rPr>
               <a:t>它能用，但我自己都不愿意每天打开它。</a:t>
             </a:r>
+            <a:endParaRPr sz="2100" b="1">
+              <a:solidFill>
+                <a:srgbClr val="2E3A45"/>
+              </a:solidFill>
+              <a:latin typeface="PingFang SC" panose="020B0400000000000000" charset="-122"/>
+            </a:endParaRPr>
           </a:p>
         </p:txBody>
       </p:sp>
@@ -4739,7 +4790,7 @@
 </file>
 
 <file path=ppt/slides/slide3.xml><?xml version="1.0" encoding="utf-8"?>
-<p:sld xmlns:a="http://schemas.openxmlformats.org/drawingml/2006/main" xmlns:p="http://schemas.openxmlformats.org/presentationml/2006/main" xmlns:r="http://schemas.openxmlformats.org/officeDocument/2006/relationships">
+<p:sld xmlns:a="http://schemas.openxmlformats.org/drawingml/2006/main" xmlns:r="http://schemas.openxmlformats.org/officeDocument/2006/relationships" xmlns:p="http://schemas.openxmlformats.org/presentationml/2006/main">
   <p:cSld>
     <p:spTree>
       <p:nvGrpSpPr>
@@ -4771,7 +4822,7 @@
                 <a:srgbClr val="F7F2E0"/>
               </a:gs>
             </a:gsLst>
-            <a:lin scaled="0" ang="16200000"/>
+            <a:lin ang="16200000" scaled="0"/>
           </a:gradFill>
           <a:ln>
             <a:noFill/>
@@ -4832,10 +4883,16 @@
                 <a:solidFill>
                   <a:srgbClr val="2E3A45"/>
                 </a:solidFill>
-                <a:latin typeface="PingFang SC"/>
+                <a:latin typeface="PingFang SC" panose="020B0400000000000000" charset="-122"/>
               </a:rPr>
               <a:t>升级不是我想加功能，是这三行字</a:t>
             </a:r>
+            <a:endParaRPr sz="4000" b="1">
+              <a:solidFill>
+                <a:srgbClr val="2E3A45"/>
+              </a:solidFill>
+              <a:latin typeface="PingFang SC" panose="020B0400000000000000" charset="-122"/>
+            </a:endParaRPr>
           </a:p>
         </p:txBody>
       </p:sp>
@@ -4871,10 +4928,16 @@
                 <a:solidFill>
                   <a:srgbClr val="61707C"/>
                 </a:solidFill>
-                <a:latin typeface="PingFang SC"/>
+                <a:latin typeface="PingFang SC" panose="020B0400000000000000" charset="-122"/>
               </a:rPr>
               <a:t>1.0 讲完那天，我写下的下周计划</a:t>
             </a:r>
+            <a:endParaRPr sz="1400" b="0">
+              <a:solidFill>
+                <a:srgbClr val="61707C"/>
+              </a:solidFill>
+              <a:latin typeface="PingFang SC" panose="020B0400000000000000" charset="-122"/>
+            </a:endParaRPr>
           </a:p>
         </p:txBody>
       </p:sp>
@@ -4910,10 +4973,16 @@
                 <a:solidFill>
                   <a:srgbClr val="61707C"/>
                 </a:solidFill>
-                <a:latin typeface="PingFang SC"/>
+                <a:latin typeface="PingFang SC" panose="020B0400000000000000" charset="-122"/>
               </a:rPr>
               <a:t>2.0 逐条做完了</a:t>
             </a:r>
+            <a:endParaRPr sz="1400" b="0">
+              <a:solidFill>
+                <a:srgbClr val="61707C"/>
+              </a:solidFill>
+              <a:latin typeface="PingFang SC" panose="020B0400000000000000" charset="-122"/>
+            </a:endParaRPr>
           </a:p>
         </p:txBody>
       </p:sp>
@@ -4958,7 +5027,7 @@
           </a:fontRef>
         </p:style>
         <p:txBody>
-          <a:bodyPr rtlCol="0" anchor="ctr" wrap="square" lIns="219456" rIns="219456" tIns="146304" bIns="146304"/>
+          <a:bodyPr wrap="square" lIns="219456" tIns="146304" rIns="219456" bIns="146304" rtlCol="0" anchor="ctr"/>
           <a:lstStyle/>
           <a:p>
             <a:pPr algn="ctr">
@@ -4971,10 +5040,16 @@
                 <a:solidFill>
                   <a:srgbClr val="2E3A45"/>
                 </a:solidFill>
-                <a:latin typeface="PingFang SC"/>
+                <a:latin typeface="PingFang SC" panose="020B0400000000000000" charset="-122"/>
               </a:rPr>
               <a:t>解决模型太慢的问题 直接用deepseek？</a:t>
             </a:r>
+            <a:endParaRPr sz="1800" b="0">
+              <a:solidFill>
+                <a:srgbClr val="2E3A45"/>
+              </a:solidFill>
+              <a:latin typeface="PingFang SC" panose="020B0400000000000000" charset="-122"/>
+            </a:endParaRPr>
           </a:p>
         </p:txBody>
       </p:sp>
@@ -5010,10 +5085,16 @@
                 <a:solidFill>
                   <a:srgbClr val="E8823C"/>
                 </a:solidFill>
-                <a:latin typeface="PingFang SC"/>
+                <a:latin typeface="PingFang SC" panose="020B0400000000000000" charset="-122"/>
               </a:rPr>
               <a:t>→</a:t>
             </a:r>
+            <a:endParaRPr sz="1800" b="1">
+              <a:solidFill>
+                <a:srgbClr val="E8823C"/>
+              </a:solidFill>
+              <a:latin typeface="PingFang SC" panose="020B0400000000000000" charset="-122"/>
+            </a:endParaRPr>
           </a:p>
         </p:txBody>
       </p:sp>
@@ -5058,7 +5139,7 @@
           </a:fontRef>
         </p:style>
         <p:txBody>
-          <a:bodyPr rtlCol="0" anchor="ctr" wrap="square" lIns="219456" rIns="219456" tIns="146304" bIns="146304"/>
+          <a:bodyPr wrap="square" lIns="219456" tIns="146304" rIns="219456" bIns="146304" rtlCol="0" anchor="ctr"/>
           <a:lstStyle/>
           <a:p>
             <a:pPr algn="ctr">
@@ -5071,10 +5152,16 @@
                 <a:solidFill>
                   <a:srgbClr val="2E3A45"/>
                 </a:solidFill>
-                <a:latin typeface="PingFang SC"/>
+                <a:latin typeface="PingFang SC" panose="020B0400000000000000" charset="-122"/>
               </a:rPr>
               <a:t>接入 DeepSeek，换掉本地小模型</a:t>
             </a:r>
+            <a:endParaRPr sz="1800" b="0">
+              <a:solidFill>
+                <a:srgbClr val="2E3A45"/>
+              </a:solidFill>
+              <a:latin typeface="PingFang SC" panose="020B0400000000000000" charset="-122"/>
+            </a:endParaRPr>
           </a:p>
         </p:txBody>
       </p:sp>
@@ -5119,7 +5206,7 @@
           </a:fontRef>
         </p:style>
         <p:txBody>
-          <a:bodyPr rtlCol="0" anchor="ctr" wrap="square" lIns="219456" rIns="219456" tIns="146304" bIns="146304"/>
+          <a:bodyPr wrap="square" lIns="219456" tIns="146304" rIns="219456" bIns="146304" rtlCol="0" anchor="ctr"/>
           <a:lstStyle/>
           <a:p>
             <a:pPr algn="ctr">
@@ -5132,10 +5219,16 @@
                 <a:solidFill>
                   <a:srgbClr val="2E3A45"/>
                 </a:solidFill>
-                <a:latin typeface="PingFang SC"/>
+                <a:latin typeface="PingFang SC" panose="020B0400000000000000" charset="-122"/>
               </a:rPr>
               <a:t>新增新用户的ai对话设置功能</a:t>
             </a:r>
+            <a:endParaRPr sz="1800" b="0">
+              <a:solidFill>
+                <a:srgbClr val="2E3A45"/>
+              </a:solidFill>
+              <a:latin typeface="PingFang SC" panose="020B0400000000000000" charset="-122"/>
+            </a:endParaRPr>
           </a:p>
         </p:txBody>
       </p:sp>
@@ -5171,10 +5264,16 @@
                 <a:solidFill>
                   <a:srgbClr val="E8823C"/>
                 </a:solidFill>
-                <a:latin typeface="PingFang SC"/>
+                <a:latin typeface="PingFang SC" panose="020B0400000000000000" charset="-122"/>
               </a:rPr>
               <a:t>→</a:t>
             </a:r>
+            <a:endParaRPr sz="1800" b="1">
+              <a:solidFill>
+                <a:srgbClr val="E8823C"/>
+              </a:solidFill>
+              <a:latin typeface="PingFang SC" panose="020B0400000000000000" charset="-122"/>
+            </a:endParaRPr>
           </a:p>
         </p:txBody>
       </p:sp>
@@ -5219,7 +5318,7 @@
           </a:fontRef>
         </p:style>
         <p:txBody>
-          <a:bodyPr rtlCol="0" anchor="ctr" wrap="square" lIns="219456" rIns="219456" tIns="146304" bIns="146304"/>
+          <a:bodyPr wrap="square" lIns="219456" tIns="146304" rIns="219456" bIns="146304" rtlCol="0" anchor="ctr"/>
           <a:lstStyle/>
           <a:p>
             <a:pPr algn="ctr">
@@ -5232,10 +5331,16 @@
                 <a:solidFill>
                   <a:srgbClr val="2E3A45"/>
                 </a:solidFill>
-                <a:latin typeface="PingFang SC"/>
+                <a:latin typeface="PingFang SC" panose="020B0400000000000000" charset="-122"/>
               </a:rPr>
               <a:t>空闲时间可以直接用一句话说</a:t>
             </a:r>
+            <a:endParaRPr sz="1800" b="0">
+              <a:solidFill>
+                <a:srgbClr val="2E3A45"/>
+              </a:solidFill>
+              <a:latin typeface="PingFang SC" panose="020B0400000000000000" charset="-122"/>
+            </a:endParaRPr>
           </a:p>
         </p:txBody>
       </p:sp>
@@ -5280,7 +5385,7 @@
           </a:fontRef>
         </p:style>
         <p:txBody>
-          <a:bodyPr rtlCol="0" anchor="ctr" wrap="square" lIns="219456" rIns="219456" tIns="146304" bIns="146304"/>
+          <a:bodyPr wrap="square" lIns="219456" tIns="146304" rIns="219456" bIns="146304" rtlCol="0" anchor="ctr"/>
           <a:lstStyle/>
           <a:p>
             <a:pPr algn="ctr">
@@ -5293,10 +5398,16 @@
                 <a:solidFill>
                   <a:srgbClr val="2E3A45"/>
                 </a:solidFill>
-                <a:latin typeface="PingFang SC"/>
+                <a:latin typeface="PingFang SC" panose="020B0400000000000000" charset="-122"/>
               </a:rPr>
               <a:t>把ai对话的界面放到一个更显眼的界面</a:t>
             </a:r>
+            <a:endParaRPr sz="1800" b="0">
+              <a:solidFill>
+                <a:srgbClr val="2E3A45"/>
+              </a:solidFill>
+              <a:latin typeface="PingFang SC" panose="020B0400000000000000" charset="-122"/>
+            </a:endParaRPr>
           </a:p>
         </p:txBody>
       </p:sp>
@@ -5332,10 +5443,16 @@
                 <a:solidFill>
                   <a:srgbClr val="E8823C"/>
                 </a:solidFill>
-                <a:latin typeface="PingFang SC"/>
+                <a:latin typeface="PingFang SC" panose="020B0400000000000000" charset="-122"/>
               </a:rPr>
               <a:t>→</a:t>
             </a:r>
+            <a:endParaRPr sz="1800" b="1">
+              <a:solidFill>
+                <a:srgbClr val="E8823C"/>
+              </a:solidFill>
+              <a:latin typeface="PingFang SC" panose="020B0400000000000000" charset="-122"/>
+            </a:endParaRPr>
           </a:p>
         </p:txBody>
       </p:sp>
@@ -5380,7 +5497,7 @@
           </a:fontRef>
         </p:style>
         <p:txBody>
-          <a:bodyPr rtlCol="0" anchor="ctr" wrap="square" lIns="219456" rIns="219456" tIns="146304" bIns="146304"/>
+          <a:bodyPr wrap="square" lIns="219456" tIns="146304" rIns="219456" bIns="146304" rtlCol="0" anchor="ctr"/>
           <a:lstStyle/>
           <a:p>
             <a:pPr algn="ctr">
@@ -5393,10 +5510,16 @@
                 <a:solidFill>
                   <a:srgbClr val="2E3A45"/>
                 </a:solidFill>
-                <a:latin typeface="PingFang SC"/>
+                <a:latin typeface="PingFang SC" panose="020B0400000000000000" charset="-122"/>
               </a:rPr>
               <a:t>对话搬到主页，成为主体交互</a:t>
             </a:r>
+            <a:endParaRPr sz="1800" b="0">
+              <a:solidFill>
+                <a:srgbClr val="2E3A45"/>
+              </a:solidFill>
+              <a:latin typeface="PingFang SC" panose="020B0400000000000000" charset="-122"/>
+            </a:endParaRPr>
           </a:p>
         </p:txBody>
       </p:sp>
@@ -5409,7 +5532,7 @@
 </file>
 
 <file path=ppt/slides/slide4.xml><?xml version="1.0" encoding="utf-8"?>
-<p:sld xmlns:a="http://schemas.openxmlformats.org/drawingml/2006/main" xmlns:p="http://schemas.openxmlformats.org/presentationml/2006/main" xmlns:r="http://schemas.openxmlformats.org/officeDocument/2006/relationships">
+<p:sld xmlns:a="http://schemas.openxmlformats.org/drawingml/2006/main" xmlns:r="http://schemas.openxmlformats.org/officeDocument/2006/relationships" xmlns:p="http://schemas.openxmlformats.org/presentationml/2006/main">
   <p:cSld>
     <p:spTree>
       <p:nvGrpSpPr>
@@ -5441,7 +5564,7 @@
                 <a:srgbClr val="F7F2E0"/>
               </a:gs>
             </a:gsLst>
-            <a:lin scaled="0" ang="16200000"/>
+            <a:lin ang="16200000" scaled="0"/>
           </a:gradFill>
           <a:ln>
             <a:noFill/>
@@ -5502,10 +5625,16 @@
                 <a:solidFill>
                   <a:srgbClr val="2E3A45"/>
                 </a:solidFill>
-                <a:latin typeface="PingFang SC"/>
+                <a:latin typeface="PingFang SC" panose="020B0400000000000000" charset="-122"/>
               </a:rPr>
               <a:t>现场看一次：从一句话到一张时间表</a:t>
             </a:r>
+            <a:endParaRPr sz="4000" b="1">
+              <a:solidFill>
+                <a:srgbClr val="2E3A45"/>
+              </a:solidFill>
+              <a:latin typeface="PingFang SC" panose="020B0400000000000000" charset="-122"/>
+            </a:endParaRPr>
           </a:p>
         </p:txBody>
       </p:sp>
@@ -5550,7 +5679,7 @@
           </a:fontRef>
         </p:style>
         <p:txBody>
-          <a:bodyPr rtlCol="0" anchor="ctr" wrap="square" lIns="54864" rIns="54864"/>
+          <a:bodyPr wrap="square" lIns="54864" rIns="54864" rtlCol="0" anchor="ctr"/>
           <a:lstStyle/>
           <a:p>
             <a:pPr algn="ctr">
@@ -5563,10 +5692,16 @@
                 <a:solidFill>
                   <a:srgbClr val="2E3A45"/>
                 </a:solidFill>
-                <a:latin typeface="PingFang SC"/>
+                <a:latin typeface="PingFang SC" panose="020B0400000000000000" charset="-122"/>
               </a:rPr>
               <a:t>遇到问题</a:t>
             </a:r>
+            <a:endParaRPr sz="1500" b="0">
+              <a:solidFill>
+                <a:srgbClr val="2E3A45"/>
+              </a:solidFill>
+              <a:latin typeface="PingFang SC" panose="020B0400000000000000" charset="-122"/>
+            </a:endParaRPr>
           </a:p>
         </p:txBody>
       </p:sp>
@@ -5602,10 +5737,16 @@
                 <a:solidFill>
                   <a:srgbClr val="E8823C"/>
                 </a:solidFill>
-                <a:latin typeface="PingFang SC"/>
+                <a:latin typeface="PingFang SC" panose="020B0400000000000000" charset="-122"/>
               </a:rPr>
               <a:t>→</a:t>
             </a:r>
+            <a:endParaRPr sz="1800" b="1">
+              <a:solidFill>
+                <a:srgbClr val="E8823C"/>
+              </a:solidFill>
+              <a:latin typeface="PingFang SC" panose="020B0400000000000000" charset="-122"/>
+            </a:endParaRPr>
           </a:p>
         </p:txBody>
       </p:sp>
@@ -5650,7 +5791,7 @@
           </a:fontRef>
         </p:style>
         <p:txBody>
-          <a:bodyPr rtlCol="0" anchor="ctr" wrap="square" lIns="54864" rIns="54864"/>
+          <a:bodyPr wrap="square" lIns="54864" rIns="54864" rtlCol="0" anchor="ctr"/>
           <a:lstStyle/>
           <a:p>
             <a:pPr algn="ctr">
@@ -5663,10 +5804,16 @@
                 <a:solidFill>
                   <a:srgbClr val="2E3A45"/>
                 </a:solidFill>
-                <a:latin typeface="PingFang SC"/>
+                <a:latin typeface="PingFang SC" panose="020B0400000000000000" charset="-122"/>
               </a:rPr>
               <a:t>一句话输入</a:t>
             </a:r>
+            <a:endParaRPr sz="1500" b="1">
+              <a:solidFill>
+                <a:srgbClr val="2E3A45"/>
+              </a:solidFill>
+              <a:latin typeface="PingFang SC" panose="020B0400000000000000" charset="-122"/>
+            </a:endParaRPr>
           </a:p>
         </p:txBody>
       </p:sp>
@@ -5702,10 +5849,16 @@
                 <a:solidFill>
                   <a:srgbClr val="E8823C"/>
                 </a:solidFill>
-                <a:latin typeface="PingFang SC"/>
+                <a:latin typeface="PingFang SC" panose="020B0400000000000000" charset="-122"/>
               </a:rPr>
               <a:t>→</a:t>
             </a:r>
+            <a:endParaRPr sz="1800" b="1">
+              <a:solidFill>
+                <a:srgbClr val="E8823C"/>
+              </a:solidFill>
+              <a:latin typeface="PingFang SC" panose="020B0400000000000000" charset="-122"/>
+            </a:endParaRPr>
           </a:p>
         </p:txBody>
       </p:sp>
@@ -5750,7 +5903,7 @@
           </a:fontRef>
         </p:style>
         <p:txBody>
-          <a:bodyPr rtlCol="0" anchor="ctr" wrap="square" lIns="54864" rIns="54864"/>
+          <a:bodyPr wrap="square" lIns="54864" rIns="54864" rtlCol="0" anchor="ctr"/>
           <a:lstStyle/>
           <a:p>
             <a:pPr algn="ctr">
@@ -5763,10 +5916,16 @@
                 <a:solidFill>
                   <a:srgbClr val="2E3A45"/>
                 </a:solidFill>
-                <a:latin typeface="PingFang SC"/>
+                <a:latin typeface="PingFang SC" panose="020B0400000000000000" charset="-122"/>
               </a:rPr>
               <a:t>AI 自己调工具</a:t>
             </a:r>
+            <a:endParaRPr sz="1500" b="0">
+              <a:solidFill>
+                <a:srgbClr val="2E3A45"/>
+              </a:solidFill>
+              <a:latin typeface="PingFang SC" panose="020B0400000000000000" charset="-122"/>
+            </a:endParaRPr>
           </a:p>
         </p:txBody>
       </p:sp>
@@ -5802,10 +5961,16 @@
                 <a:solidFill>
                   <a:srgbClr val="E8823C"/>
                 </a:solidFill>
-                <a:latin typeface="PingFang SC"/>
+                <a:latin typeface="PingFang SC" panose="020B0400000000000000" charset="-122"/>
               </a:rPr>
               <a:t>→</a:t>
             </a:r>
+            <a:endParaRPr sz="1800" b="1">
+              <a:solidFill>
+                <a:srgbClr val="E8823C"/>
+              </a:solidFill>
+              <a:latin typeface="PingFang SC" panose="020B0400000000000000" charset="-122"/>
+            </a:endParaRPr>
           </a:p>
         </p:txBody>
       </p:sp>
@@ -5850,7 +6015,7 @@
           </a:fontRef>
         </p:style>
         <p:txBody>
-          <a:bodyPr rtlCol="0" anchor="ctr" wrap="square" lIns="54864" rIns="54864"/>
+          <a:bodyPr wrap="square" lIns="54864" rIns="54864" rtlCol="0" anchor="ctr"/>
           <a:lstStyle/>
           <a:p>
             <a:pPr algn="ctr">
@@ -5863,10 +6028,16 @@
                 <a:solidFill>
                   <a:srgbClr val="2E3A45"/>
                 </a:solidFill>
-                <a:latin typeface="PingFang SC"/>
+                <a:latin typeface="PingFang SC" panose="020B0400000000000000" charset="-122"/>
               </a:rPr>
               <a:t>可编辑时间轴</a:t>
             </a:r>
+            <a:endParaRPr sz="1500" b="0">
+              <a:solidFill>
+                <a:srgbClr val="2E3A45"/>
+              </a:solidFill>
+              <a:latin typeface="PingFang SC" panose="020B0400000000000000" charset="-122"/>
+            </a:endParaRPr>
           </a:p>
         </p:txBody>
       </p:sp>
@@ -5902,10 +6073,16 @@
                 <a:solidFill>
                   <a:srgbClr val="E8823C"/>
                 </a:solidFill>
-                <a:latin typeface="PingFang SC"/>
+                <a:latin typeface="PingFang SC" panose="020B0400000000000000" charset="-122"/>
               </a:rPr>
               <a:t>→</a:t>
             </a:r>
+            <a:endParaRPr sz="1800" b="1">
+              <a:solidFill>
+                <a:srgbClr val="E8823C"/>
+              </a:solidFill>
+              <a:latin typeface="PingFang SC" panose="020B0400000000000000" charset="-122"/>
+            </a:endParaRPr>
           </a:p>
         </p:txBody>
       </p:sp>
@@ -5950,7 +6127,7 @@
           </a:fontRef>
         </p:style>
         <p:txBody>
-          <a:bodyPr rtlCol="0" anchor="ctr" wrap="square" lIns="54864" rIns="54864"/>
+          <a:bodyPr wrap="square" lIns="54864" rIns="54864" rtlCol="0" anchor="ctr"/>
           <a:lstStyle/>
           <a:p>
             <a:pPr algn="ctr">
@@ -5963,10 +6140,16 @@
                 <a:solidFill>
                   <a:srgbClr val="2E3A45"/>
                 </a:solidFill>
-                <a:latin typeface="PingFang SC"/>
+                <a:latin typeface="PingFang SC" panose="020B0400000000000000" charset="-122"/>
               </a:rPr>
               <a:t>知道今天先做什么</a:t>
             </a:r>
+            <a:endParaRPr sz="1500" b="0">
+              <a:solidFill>
+                <a:srgbClr val="2E3A45"/>
+              </a:solidFill>
+              <a:latin typeface="PingFang SC" panose="020B0400000000000000" charset="-122"/>
+            </a:endParaRPr>
           </a:p>
         </p:txBody>
       </p:sp>
@@ -6011,7 +6194,7 @@
           </a:fontRef>
         </p:style>
         <p:txBody>
-          <a:bodyPr rtlCol="0" anchor="ctr" wrap="square" lIns="219456" rIns="219456" tIns="146304" bIns="146304"/>
+          <a:bodyPr wrap="square" lIns="219456" tIns="146304" rIns="219456" bIns="146304" rtlCol="0" anchor="ctr"/>
           <a:lstStyle/>
           <a:p>
             <a:pPr algn="ctr">
@@ -6020,23 +6203,20 @@
               </a:lnSpc>
             </a:pPr>
             <a:r>
-              <a:rPr sz="2000" b="0">
+              <a:rPr sz="2200" b="0">
                 <a:solidFill>
                   <a:srgbClr val="2E3A45"/>
                 </a:solidFill>
-                <a:latin typeface="PingFang SC"/>
-              </a:rPr>
-              <a:t/>
-            </a:r>
-            <a:r>
-              <a:rPr sz="2200" b="0">
-                <a:solidFill>
-                  <a:srgbClr val="2E3A45"/>
-                </a:solidFill>
-                <a:latin typeface="PingFang SC"/>
+                <a:latin typeface="PingFang SC" panose="020B0400000000000000" charset="-122"/>
               </a:rPr>
               <a:t>工作日晚上7点到9点有空，数学卷3张周一前，帮我排计划</a:t>
             </a:r>
+            <a:endParaRPr sz="2200" b="0">
+              <a:solidFill>
+                <a:srgbClr val="2E3A45"/>
+              </a:solidFill>
+              <a:latin typeface="PingFang SC" panose="020B0400000000000000" charset="-122"/>
+            </a:endParaRPr>
           </a:p>
         </p:txBody>
       </p:sp>
@@ -6049,7 +6229,7 @@
 </file>
 
 <file path=ppt/slides/slide5.xml><?xml version="1.0" encoding="utf-8"?>
-<p:sld xmlns:a="http://schemas.openxmlformats.org/drawingml/2006/main" xmlns:p="http://schemas.openxmlformats.org/presentationml/2006/main" xmlns:r="http://schemas.openxmlformats.org/officeDocument/2006/relationships">
+<p:sld xmlns:a="http://schemas.openxmlformats.org/drawingml/2006/main" xmlns:r="http://schemas.openxmlformats.org/officeDocument/2006/relationships" xmlns:p="http://schemas.openxmlformats.org/presentationml/2006/main">
   <p:cSld>
     <p:spTree>
       <p:nvGrpSpPr>
@@ -6081,7 +6261,7 @@
                 <a:srgbClr val="F7F2E0"/>
               </a:gs>
             </a:gsLst>
-            <a:lin scaled="0" ang="16200000"/>
+            <a:lin ang="16200000" scaled="0"/>
           </a:gradFill>
           <a:ln>
             <a:noFill/>
@@ -6142,10 +6322,16 @@
                 <a:solidFill>
                   <a:srgbClr val="2E3A45"/>
                 </a:solidFill>
-                <a:latin typeface="PingFang SC"/>
+                <a:latin typeface="PingFang SC" panose="020B0400000000000000" charset="-122"/>
               </a:rPr>
               <a:t>我把 AI 对话搬到了主页正中央</a:t>
             </a:r>
+            <a:endParaRPr sz="4000" b="1">
+              <a:solidFill>
+                <a:srgbClr val="2E3A45"/>
+              </a:solidFill>
+              <a:latin typeface="PingFang SC" panose="020B0400000000000000" charset="-122"/>
+            </a:endParaRPr>
           </a:p>
         </p:txBody>
       </p:sp>
@@ -6181,10 +6367,16 @@
                 <a:solidFill>
                   <a:srgbClr val="61707C"/>
                 </a:solidFill>
-                <a:latin typeface="PingFang SC"/>
+                <a:latin typeface="PingFang SC" panose="020B0400000000000000" charset="-122"/>
               </a:rPr>
               <a:t>1.0　手机小屏</a:t>
             </a:r>
+            <a:endParaRPr sz="1400" b="0">
+              <a:solidFill>
+                <a:srgbClr val="61707C"/>
+              </a:solidFill>
+              <a:latin typeface="PingFang SC" panose="020B0400000000000000" charset="-122"/>
+            </a:endParaRPr>
           </a:p>
         </p:txBody>
       </p:sp>
@@ -6220,10 +6412,16 @@
                 <a:solidFill>
                   <a:srgbClr val="61707C"/>
                 </a:solidFill>
-                <a:latin typeface="PingFang SC"/>
+                <a:latin typeface="PingFang SC" panose="020B0400000000000000" charset="-122"/>
               </a:rPr>
               <a:t>2.0　电脑网页三栏</a:t>
             </a:r>
+            <a:endParaRPr sz="1400" b="0">
+              <a:solidFill>
+                <a:srgbClr val="61707C"/>
+              </a:solidFill>
+              <a:latin typeface="PingFang SC" panose="020B0400000000000000" charset="-122"/>
+            </a:endParaRPr>
           </a:p>
         </p:txBody>
       </p:sp>
@@ -6268,7 +6466,7 @@
           </a:fontRef>
         </p:style>
         <p:txBody>
-          <a:bodyPr rtlCol="0" anchor="ctr" wrap="square" lIns="219456" rIns="219456" tIns="146304" bIns="146304"/>
+          <a:bodyPr wrap="square" lIns="219456" tIns="146304" rIns="219456" bIns="146304" rtlCol="0" anchor="ctr"/>
           <a:lstStyle/>
           <a:p>
             <a:pPr algn="ctr">
@@ -6281,10 +6479,16 @@
                 <a:solidFill>
                   <a:srgbClr val="2E3A45"/>
                 </a:solidFill>
-                <a:latin typeface="PingFang SC"/>
+                <a:latin typeface="PingFang SC" panose="020B0400000000000000" charset="-122"/>
               </a:rPr>
               <a:t>主页只有一个计时器，要录任务得先切到计划列表填表</a:t>
             </a:r>
+            <a:endParaRPr sz="1900" b="0">
+              <a:solidFill>
+                <a:srgbClr val="2E3A45"/>
+              </a:solidFill>
+              <a:latin typeface="PingFang SC" panose="020B0400000000000000" charset="-122"/>
+            </a:endParaRPr>
           </a:p>
         </p:txBody>
       </p:sp>
@@ -6320,10 +6524,16 @@
                 <a:solidFill>
                   <a:srgbClr val="E8823C"/>
                 </a:solidFill>
-                <a:latin typeface="PingFang SC"/>
+                <a:latin typeface="PingFang SC" panose="020B0400000000000000" charset="-122"/>
               </a:rPr>
               <a:t>→</a:t>
             </a:r>
+            <a:endParaRPr sz="1800" b="1">
+              <a:solidFill>
+                <a:srgbClr val="E8823C"/>
+              </a:solidFill>
+              <a:latin typeface="PingFang SC" panose="020B0400000000000000" charset="-122"/>
+            </a:endParaRPr>
           </a:p>
         </p:txBody>
       </p:sp>
@@ -6368,7 +6578,7 @@
           </a:fontRef>
         </p:style>
         <p:txBody>
-          <a:bodyPr rtlCol="0" anchor="ctr" wrap="square" lIns="219456" rIns="219456" tIns="146304" bIns="146304"/>
+          <a:bodyPr wrap="square" lIns="219456" tIns="146304" rIns="219456" bIns="146304" rtlCol="0" anchor="ctr"/>
           <a:lstStyle/>
           <a:p>
             <a:pPr algn="ctr">
@@ -6381,10 +6591,16 @@
                 <a:solidFill>
                   <a:srgbClr val="2E3A45"/>
                 </a:solidFill>
-                <a:latin typeface="PingFang SC"/>
+                <a:latin typeface="PingFang SC" panose="020B0400000000000000" charset="-122"/>
               </a:rPr>
               <a:t>打开就能直接跟 AI 说话，看板一屏铺开</a:t>
             </a:r>
+            <a:endParaRPr sz="1900" b="0">
+              <a:solidFill>
+                <a:srgbClr val="2E3A45"/>
+              </a:solidFill>
+              <a:latin typeface="PingFang SC" panose="020B0400000000000000" charset="-122"/>
+            </a:endParaRPr>
           </a:p>
         </p:txBody>
       </p:sp>
@@ -6429,7 +6645,7 @@
           </a:fontRef>
         </p:style>
         <p:txBody>
-          <a:bodyPr rtlCol="0" anchor="ctr" wrap="square" lIns="219456" rIns="219456" tIns="146304" bIns="146304"/>
+          <a:bodyPr wrap="square" lIns="219456" tIns="146304" rIns="219456" bIns="146304" rtlCol="0" anchor="ctr"/>
           <a:lstStyle/>
           <a:p>
             <a:pPr algn="ctr">
@@ -6442,10 +6658,16 @@
                 <a:solidFill>
                   <a:srgbClr val="61707C"/>
                 </a:solidFill>
-                <a:latin typeface="PingFang SC"/>
+                <a:latin typeface="PingFang SC" panose="020B0400000000000000" charset="-122"/>
               </a:rPr>
               <a:t>代价，以及我怎么按住它</a:t>
             </a:r>
+            <a:endParaRPr sz="1300" b="0">
+              <a:solidFill>
+                <a:srgbClr val="61707C"/>
+              </a:solidFill>
+              <a:latin typeface="PingFang SC" panose="020B0400000000000000" charset="-122"/>
+            </a:endParaRPr>
           </a:p>
           <a:p>
             <a:pPr>
@@ -6458,7 +6680,7 @@
                 <a:solidFill>
                   <a:srgbClr val="2E3A45"/>
                 </a:solidFill>
-                <a:latin typeface="PingFang SC"/>
+                <a:latin typeface="PingFang SC" panose="020B0400000000000000" charset="-122"/>
               </a:rPr>
               <a:t>AI 可能嘴上答应却不真的保存。所以提示词里写死一条硬规则——</a:t>
             </a:r>
@@ -6467,10 +6689,16 @@
                 <a:solidFill>
                   <a:srgbClr val="E8823C"/>
                 </a:solidFill>
-                <a:latin typeface="PingFang SC"/>
+                <a:latin typeface="PingFang SC" panose="020B0400000000000000" charset="-122"/>
               </a:rPr>
               <a:t>能用工具就用工具，不许假装已经保存</a:t>
             </a:r>
+            <a:endParaRPr sz="1900" b="1">
+              <a:solidFill>
+                <a:srgbClr val="E8823C"/>
+              </a:solidFill>
+              <a:latin typeface="PingFang SC" panose="020B0400000000000000" charset="-122"/>
+            </a:endParaRPr>
           </a:p>
         </p:txBody>
       </p:sp>
@@ -6483,7 +6711,7 @@
 </file>
 
 <file path=ppt/slides/slide6.xml><?xml version="1.0" encoding="utf-8"?>
-<p:sld xmlns:a="http://schemas.openxmlformats.org/drawingml/2006/main" xmlns:p="http://schemas.openxmlformats.org/presentationml/2006/main" xmlns:r="http://schemas.openxmlformats.org/officeDocument/2006/relationships">
+<p:sld xmlns:a="http://schemas.openxmlformats.org/drawingml/2006/main" xmlns:r="http://schemas.openxmlformats.org/officeDocument/2006/relationships" xmlns:p="http://schemas.openxmlformats.org/presentationml/2006/main">
   <p:cSld>
     <p:spTree>
       <p:nvGrpSpPr>
@@ -6515,7 +6743,7 @@
                 <a:srgbClr val="F7F2E0"/>
               </a:gs>
             </a:gsLst>
-            <a:lin scaled="0" ang="16200000"/>
+            <a:lin ang="16200000" scaled="0"/>
           </a:gradFill>
           <a:ln>
             <a:noFill/>
@@ -6576,7 +6804,487 @@
                 <a:solidFill>
                   <a:srgbClr val="2E3A45"/>
                 </a:solidFill>
-                <a:latin typeface="PingFang SC"/>
+                <a:latin typeface="PingFang SC" panose="020B0400000000000000" charset="-122"/>
+              </a:rPr>
+              <a:t>一次真实的崩溃，和我现在的边界</a:t>
+            </a:r>
+            <a:endParaRPr sz="4000" b="1">
+              <a:solidFill>
+                <a:srgbClr val="2E3A45"/>
+              </a:solidFill>
+              <a:latin typeface="PingFang SC" panose="020B0400000000000000" charset="-122"/>
+            </a:endParaRPr>
+          </a:p>
+        </p:txBody>
+      </p:sp>
+      <p:sp>
+        <p:nvSpPr>
+          <p:cNvPr id="4" name="Rounded Rectangle 3"/>
+          <p:cNvSpPr/>
+          <p:nvPr/>
+        </p:nvSpPr>
+        <p:spPr>
+          <a:xfrm>
+            <a:off x="713232" y="1691640"/>
+            <a:ext cx="3393338" cy="1874519"/>
+          </a:xfrm>
+          <a:prstGeom prst="roundRect">
+            <a:avLst>
+              <a:gd name="adj" fmla="val 9000"/>
+            </a:avLst>
+          </a:prstGeom>
+          <a:solidFill>
+            <a:srgbClr val="FFFFFF"/>
+          </a:solidFill>
+          <a:ln w="12700">
+            <a:solidFill>
+              <a:srgbClr val="E4ECF2"/>
+            </a:solidFill>
+          </a:ln>
+          <a:effectLst/>
+        </p:spPr>
+        <p:style>
+          <a:lnRef idx="1">
+            <a:schemeClr val="accent1"/>
+          </a:lnRef>
+          <a:fillRef idx="3">
+            <a:schemeClr val="accent1"/>
+          </a:fillRef>
+          <a:effectRef idx="2">
+            <a:schemeClr val="accent1"/>
+          </a:effectRef>
+          <a:fontRef idx="minor">
+            <a:schemeClr val="lt1"/>
+          </a:fontRef>
+        </p:style>
+        <p:txBody>
+          <a:bodyPr wrap="square" lIns="219456" tIns="146304" rIns="219456" bIns="146304" rtlCol="0" anchor="ctr"/>
+          <a:lstStyle/>
+          <a:p>
+            <a:pPr algn="ctr">
+              <a:lnSpc>
+                <a:spcPct val="135000"/>
+              </a:lnSpc>
+            </a:pPr>
+            <a:r>
+              <a:rPr sz="1300" b="0">
+                <a:solidFill>
+                  <a:srgbClr val="61707C"/>
+                </a:solidFill>
+                <a:latin typeface="PingFang SC" panose="020B0400000000000000" charset="-122"/>
+              </a:rPr>
+              <a:t>现象</a:t>
+            </a:r>
+            <a:endParaRPr sz="1300" b="0">
+              <a:solidFill>
+                <a:srgbClr val="61707C"/>
+              </a:solidFill>
+              <a:latin typeface="PingFang SC" panose="020B0400000000000000" charset="-122"/>
+            </a:endParaRPr>
+          </a:p>
+          <a:p>
+            <a:pPr>
+              <a:lnSpc>
+                <a:spcPct val="135000"/>
+              </a:lnSpc>
+            </a:pPr>
+            <a:r>
+              <a:rPr sz="1800" b="0">
+                <a:solidFill>
+                  <a:srgbClr val="2E3A45"/>
+                </a:solidFill>
+                <a:latin typeface="PingFang SC" panose="020B0400000000000000" charset="-122"/>
+              </a:rPr>
+              <a:t>后端刚启动时第一个请求会连接超时，1.0 直接崩掉，页面一片空白</a:t>
+            </a:r>
+            <a:endParaRPr sz="1800" b="0">
+              <a:solidFill>
+                <a:srgbClr val="2E3A45"/>
+              </a:solidFill>
+              <a:latin typeface="PingFang SC" panose="020B0400000000000000" charset="-122"/>
+            </a:endParaRPr>
+          </a:p>
+        </p:txBody>
+      </p:sp>
+      <p:sp>
+        <p:nvSpPr>
+          <p:cNvPr id="5" name="Rounded Rectangle 4"/>
+          <p:cNvSpPr/>
+          <p:nvPr/>
+        </p:nvSpPr>
+        <p:spPr>
+          <a:xfrm>
+            <a:off x="4399178" y="1691640"/>
+            <a:ext cx="3393338" cy="1874519"/>
+          </a:xfrm>
+          <a:prstGeom prst="roundRect">
+            <a:avLst>
+              <a:gd name="adj" fmla="val 9000"/>
+            </a:avLst>
+          </a:prstGeom>
+          <a:solidFill>
+            <a:srgbClr val="FFFFFF"/>
+          </a:solidFill>
+          <a:ln w="12700">
+            <a:solidFill>
+              <a:srgbClr val="E4ECF2"/>
+            </a:solidFill>
+          </a:ln>
+          <a:effectLst/>
+        </p:spPr>
+        <p:style>
+          <a:lnRef idx="1">
+            <a:schemeClr val="accent1"/>
+          </a:lnRef>
+          <a:fillRef idx="3">
+            <a:schemeClr val="accent1"/>
+          </a:fillRef>
+          <a:effectRef idx="2">
+            <a:schemeClr val="accent1"/>
+          </a:effectRef>
+          <a:fontRef idx="minor">
+            <a:schemeClr val="lt1"/>
+          </a:fontRef>
+        </p:style>
+        <p:txBody>
+          <a:bodyPr wrap="square" lIns="219456" tIns="146304" rIns="219456" bIns="146304" rtlCol="0" anchor="ctr"/>
+          <a:lstStyle/>
+          <a:p>
+            <a:pPr algn="ctr">
+              <a:lnSpc>
+                <a:spcPct val="135000"/>
+              </a:lnSpc>
+            </a:pPr>
+            <a:r>
+              <a:rPr sz="1300" b="0">
+                <a:solidFill>
+                  <a:srgbClr val="61707C"/>
+                </a:solidFill>
+                <a:latin typeface="PingFang SC" panose="020B0400000000000000" charset="-122"/>
+              </a:rPr>
+              <a:t>修改</a:t>
+            </a:r>
+            <a:endParaRPr sz="1300" b="0">
+              <a:solidFill>
+                <a:srgbClr val="61707C"/>
+              </a:solidFill>
+              <a:latin typeface="PingFang SC" panose="020B0400000000000000" charset="-122"/>
+            </a:endParaRPr>
+          </a:p>
+          <a:p>
+            <a:pPr>
+              <a:lnSpc>
+                <a:spcPct val="135000"/>
+              </a:lnSpc>
+            </a:pPr>
+            <a:r>
+              <a:rPr sz="1800" b="0">
+                <a:solidFill>
+                  <a:srgbClr val="2E3A45"/>
+                </a:solidFill>
+                <a:latin typeface="PingFang SC" panose="020B0400000000000000" charset="-122"/>
+              </a:rPr>
+              <a:t>请求前先花 3 秒探活，模型不可用就返回一句中文提示，超时单独处理</a:t>
+            </a:r>
+            <a:endParaRPr sz="1800" b="0">
+              <a:solidFill>
+                <a:srgbClr val="2E3A45"/>
+              </a:solidFill>
+              <a:latin typeface="PingFang SC" panose="020B0400000000000000" charset="-122"/>
+            </a:endParaRPr>
+          </a:p>
+        </p:txBody>
+      </p:sp>
+      <p:sp>
+        <p:nvSpPr>
+          <p:cNvPr id="6" name="Rounded Rectangle 5"/>
+          <p:cNvSpPr/>
+          <p:nvPr/>
+        </p:nvSpPr>
+        <p:spPr>
+          <a:xfrm>
+            <a:off x="8085124" y="1691640"/>
+            <a:ext cx="3393338" cy="1874519"/>
+          </a:xfrm>
+          <a:prstGeom prst="roundRect">
+            <a:avLst>
+              <a:gd name="adj" fmla="val 9000"/>
+            </a:avLst>
+          </a:prstGeom>
+          <a:solidFill>
+            <a:srgbClr val="FFFFFF"/>
+          </a:solidFill>
+          <a:ln w="12700">
+            <a:solidFill>
+              <a:srgbClr val="E4ECF2"/>
+            </a:solidFill>
+          </a:ln>
+          <a:effectLst/>
+        </p:spPr>
+        <p:style>
+          <a:lnRef idx="1">
+            <a:schemeClr val="accent1"/>
+          </a:lnRef>
+          <a:fillRef idx="3">
+            <a:schemeClr val="accent1"/>
+          </a:fillRef>
+          <a:effectRef idx="2">
+            <a:schemeClr val="accent1"/>
+          </a:effectRef>
+          <a:fontRef idx="minor">
+            <a:schemeClr val="lt1"/>
+          </a:fontRef>
+        </p:style>
+        <p:txBody>
+          <a:bodyPr wrap="square" lIns="219456" tIns="146304" rIns="219456" bIns="146304" rtlCol="0" anchor="ctr"/>
+          <a:lstStyle/>
+          <a:p>
+            <a:pPr algn="ctr">
+              <a:lnSpc>
+                <a:spcPct val="135000"/>
+              </a:lnSpc>
+            </a:pPr>
+            <a:r>
+              <a:rPr sz="1300" b="0">
+                <a:solidFill>
+                  <a:srgbClr val="61707C"/>
+                </a:solidFill>
+                <a:latin typeface="PingFang SC" panose="020B0400000000000000" charset="-122"/>
+              </a:rPr>
+              <a:t>结果</a:t>
+            </a:r>
+            <a:endParaRPr sz="1300" b="0">
+              <a:solidFill>
+                <a:srgbClr val="61707C"/>
+              </a:solidFill>
+              <a:latin typeface="PingFang SC" panose="020B0400000000000000" charset="-122"/>
+            </a:endParaRPr>
+          </a:p>
+          <a:p>
+            <a:pPr>
+              <a:lnSpc>
+                <a:spcPct val="135000"/>
+              </a:lnSpc>
+            </a:pPr>
+            <a:r>
+              <a:rPr sz="1800" b="0">
+                <a:solidFill>
+                  <a:srgbClr val="2E3A45"/>
+                </a:solidFill>
+                <a:latin typeface="PingFang SC" panose="020B0400000000000000" charset="-122"/>
+              </a:rPr>
+              <a:t>最坏情况是看到一句「DeepSeek 暂时不可用」，产品还在，</a:t>
+            </a:r>
+            <a:r>
+              <a:rPr sz="1800" b="1">
+                <a:solidFill>
+                  <a:srgbClr val="E8823C"/>
+                </a:solidFill>
+                <a:latin typeface="PingFang SC" panose="020B0400000000000000" charset="-122"/>
+              </a:rPr>
+              <a:t>不会白屏</a:t>
+            </a:r>
+            <a:endParaRPr sz="1800" b="1">
+              <a:solidFill>
+                <a:srgbClr val="E8823C"/>
+              </a:solidFill>
+              <a:latin typeface="PingFang SC" panose="020B0400000000000000" charset="-122"/>
+            </a:endParaRPr>
+          </a:p>
+        </p:txBody>
+      </p:sp>
+      <p:sp>
+        <p:nvSpPr>
+          <p:cNvPr id="7" name="Rounded Rectangle 6"/>
+          <p:cNvSpPr/>
+          <p:nvPr/>
+        </p:nvSpPr>
+        <p:spPr>
+          <a:xfrm>
+            <a:off x="713232" y="3931920"/>
+            <a:ext cx="10765231" cy="1234440"/>
+          </a:xfrm>
+          <a:prstGeom prst="roundRect">
+            <a:avLst>
+              <a:gd name="adj" fmla="val 9000"/>
+            </a:avLst>
+          </a:prstGeom>
+          <a:solidFill>
+            <a:srgbClr val="F6F4EE"/>
+          </a:solidFill>
+          <a:ln w="12700">
+            <a:solidFill>
+              <a:srgbClr val="E4ECF2"/>
+            </a:solidFill>
+          </a:ln>
+          <a:effectLst/>
+        </p:spPr>
+        <p:style>
+          <a:lnRef idx="1">
+            <a:schemeClr val="accent1"/>
+          </a:lnRef>
+          <a:fillRef idx="3">
+            <a:schemeClr val="accent1"/>
+          </a:fillRef>
+          <a:effectRef idx="2">
+            <a:schemeClr val="accent1"/>
+          </a:effectRef>
+          <a:fontRef idx="minor">
+            <a:schemeClr val="lt1"/>
+          </a:fontRef>
+        </p:style>
+        <p:txBody>
+          <a:bodyPr wrap="square" lIns="219456" tIns="146304" rIns="219456" bIns="146304" rtlCol="0" anchor="ctr"/>
+          <a:lstStyle/>
+          <a:p>
+            <a:pPr algn="ctr">
+              <a:lnSpc>
+                <a:spcPct val="135000"/>
+              </a:lnSpc>
+            </a:pPr>
+            <a:r>
+              <a:rPr sz="1300" b="0">
+                <a:solidFill>
+                  <a:srgbClr val="61707C"/>
+                </a:solidFill>
+                <a:latin typeface="PingFang SC" panose="020B0400000000000000" charset="-122"/>
+              </a:rPr>
+              <a:t>我还没解决的</a:t>
+            </a:r>
+            <a:endParaRPr sz="1300" b="0">
+              <a:solidFill>
+                <a:srgbClr val="61707C"/>
+              </a:solidFill>
+              <a:latin typeface="PingFang SC" panose="020B0400000000000000" charset="-122"/>
+            </a:endParaRPr>
+          </a:p>
+          <a:p>
+            <a:pPr>
+              <a:lnSpc>
+                <a:spcPct val="135000"/>
+              </a:lnSpc>
+            </a:pPr>
+            <a:r>
+              <a:rPr sz="1800" b="0">
+                <a:solidFill>
+                  <a:srgbClr val="2E3A45"/>
+                </a:solidFill>
+                <a:latin typeface="PingFang SC" panose="020B0400000000000000" charset="-122"/>
+              </a:rPr>
+              <a:t>失败后不会自动重试，得手动再发一次　·　对话没有逐字输出　·　估时的检索还比较粗糙</a:t>
+            </a:r>
+            <a:endParaRPr sz="1800" b="0">
+              <a:solidFill>
+                <a:srgbClr val="2E3A45"/>
+              </a:solidFill>
+              <a:latin typeface="PingFang SC" panose="020B0400000000000000" charset="-122"/>
+            </a:endParaRPr>
+          </a:p>
+        </p:txBody>
+      </p:sp>
+    </p:spTree>
+  </p:cSld>
+  <p:clrMapOvr>
+    <a:masterClrMapping/>
+  </p:clrMapOvr>
+</p:sld>
+</file>
+
+<file path=ppt/slides/slide7.xml><?xml version="1.0" encoding="utf-8"?>
+<p:sld xmlns:a="http://schemas.openxmlformats.org/drawingml/2006/main" xmlns:r="http://schemas.openxmlformats.org/officeDocument/2006/relationships" xmlns:p="http://schemas.openxmlformats.org/presentationml/2006/main">
+  <p:cSld>
+    <p:spTree>
+      <p:nvGrpSpPr>
+        <p:cNvPr id="1" name=""/>
+        <p:cNvGrpSpPr/>
+        <p:nvPr/>
+      </p:nvGrpSpPr>
+      <p:grpSpPr/>
+      <p:sp>
+        <p:nvSpPr>
+          <p:cNvPr id="2" name="Rectangle 1"/>
+          <p:cNvSpPr/>
+          <p:nvPr/>
+        </p:nvSpPr>
+        <p:spPr>
+          <a:xfrm>
+            <a:off x="0" y="0"/>
+            <a:ext cx="12191695" cy="6858000"/>
+          </a:xfrm>
+          <a:prstGeom prst="rect">
+            <a:avLst/>
+          </a:prstGeom>
+          <a:gradFill rotWithShape="1">
+            <a:gsLst>
+              <a:gs pos="0">
+                <a:srgbClr val="A8D8F0"/>
+              </a:gs>
+              <a:gs pos="100000">
+                <a:srgbClr val="F7F2E0"/>
+              </a:gs>
+            </a:gsLst>
+            <a:lin ang="16200000" scaled="0"/>
+          </a:gradFill>
+          <a:ln>
+            <a:noFill/>
+          </a:ln>
+          <a:effectLst/>
+        </p:spPr>
+        <p:style>
+          <a:lnRef idx="1">
+            <a:schemeClr val="accent1"/>
+          </a:lnRef>
+          <a:fillRef idx="3">
+            <a:schemeClr val="accent1"/>
+          </a:fillRef>
+          <a:effectRef idx="2">
+            <a:schemeClr val="accent1"/>
+          </a:effectRef>
+          <a:fontRef idx="minor">
+            <a:schemeClr val="lt1"/>
+          </a:fontRef>
+        </p:style>
+        <p:txBody>
+          <a:bodyPr rtlCol="0" anchor="ctr"/>
+          <a:lstStyle/>
+          <a:p>
+            <a:pPr algn="ctr"/>
+          </a:p>
+        </p:txBody>
+      </p:sp>
+      <p:sp>
+        <p:nvSpPr>
+          <p:cNvPr id="3" name="TextBox 2"/>
+          <p:cNvSpPr txBox="1"/>
+          <p:nvPr/>
+        </p:nvSpPr>
+        <p:spPr>
+          <a:xfrm>
+            <a:off x="713232" y="566928"/>
+            <a:ext cx="10765231" cy="914400"/>
+          </a:xfrm>
+          <a:prstGeom prst="rect">
+            <a:avLst/>
+          </a:prstGeom>
+          <a:noFill/>
+        </p:spPr>
+        <p:txBody>
+          <a:bodyPr wrap="square" anchor="t">
+            <a:spAutoFit/>
+          </a:bodyPr>
+          <a:lstStyle/>
+          <a:p>
+            <a:pPr algn="l">
+              <a:lnSpc>
+                <a:spcPct val="120000"/>
+              </a:lnSpc>
+            </a:pPr>
+            <a:r>
+              <a:rPr sz="4000" b="1">
+                <a:solidFill>
+                  <a:srgbClr val="2E3A45"/>
+                </a:solidFill>
+                <a:latin typeface="PingFang SC" panose="020B0400000000000000" charset="-122"/>
               </a:rPr>
               <a:t>AI 凭什么说这张卷子要 </a:t>
             </a:r>
@@ -6585,10 +7293,16 @@
                 <a:solidFill>
                   <a:srgbClr val="E8823C"/>
                 </a:solidFill>
-                <a:latin typeface="PingFang SC"/>
+                <a:latin typeface="PingFang SC" panose="020B0400000000000000" charset="-122"/>
               </a:rPr>
               <a:t>375 分钟</a:t>
             </a:r>
+            <a:endParaRPr sz="4000" b="1">
+              <a:solidFill>
+                <a:srgbClr val="E8823C"/>
+              </a:solidFill>
+              <a:latin typeface="PingFang SC" panose="020B0400000000000000" charset="-122"/>
+            </a:endParaRPr>
           </a:p>
         </p:txBody>
       </p:sp>
@@ -6633,7 +7347,7 @@
           </a:fontRef>
         </p:style>
         <p:txBody>
-          <a:bodyPr rtlCol="0" anchor="ctr" wrap="square" lIns="54864" rIns="54864"/>
+          <a:bodyPr wrap="square" lIns="54864" rIns="54864" rtlCol="0" anchor="ctr"/>
           <a:lstStyle/>
           <a:p>
             <a:pPr algn="ctr">
@@ -6646,10 +7360,16 @@
                 <a:solidFill>
                   <a:srgbClr val="2E3A45"/>
                 </a:solidFill>
-                <a:latin typeface="PingFang SC"/>
+                <a:latin typeface="PingFang SC" panose="020B0400000000000000" charset="-122"/>
               </a:rPr>
               <a:t>「数学卷3张」</a:t>
             </a:r>
+            <a:endParaRPr sz="1500" b="0">
+              <a:solidFill>
+                <a:srgbClr val="2E3A45"/>
+              </a:solidFill>
+              <a:latin typeface="PingFang SC" panose="020B0400000000000000" charset="-122"/>
+            </a:endParaRPr>
           </a:p>
         </p:txBody>
       </p:sp>
@@ -6685,10 +7405,16 @@
                 <a:solidFill>
                   <a:srgbClr val="E8823C"/>
                 </a:solidFill>
-                <a:latin typeface="PingFang SC"/>
+                <a:latin typeface="PingFang SC" panose="020B0400000000000000" charset="-122"/>
               </a:rPr>
               <a:t>→</a:t>
             </a:r>
+            <a:endParaRPr sz="1800" b="1">
+              <a:solidFill>
+                <a:srgbClr val="E8823C"/>
+              </a:solidFill>
+              <a:latin typeface="PingFang SC" panose="020B0400000000000000" charset="-122"/>
+            </a:endParaRPr>
           </a:p>
         </p:txBody>
       </p:sp>
@@ -6733,7 +7459,7 @@
           </a:fontRef>
         </p:style>
         <p:txBody>
-          <a:bodyPr rtlCol="0" anchor="ctr" wrap="square" lIns="54864" rIns="54864"/>
+          <a:bodyPr wrap="square" lIns="54864" rIns="54864" rtlCol="0" anchor="ctr"/>
           <a:lstStyle/>
           <a:p>
             <a:pPr algn="ctr">
@@ -6746,10 +7472,16 @@
                 <a:solidFill>
                   <a:srgbClr val="2E3A45"/>
                 </a:solidFill>
-                <a:latin typeface="PingFang SC"/>
+                <a:latin typeface="PingFang SC" panose="020B0400000000000000" charset="-122"/>
               </a:rPr>
               <a:t>抽出数量 3</a:t>
             </a:r>
+            <a:endParaRPr sz="1500" b="0">
+              <a:solidFill>
+                <a:srgbClr val="2E3A45"/>
+              </a:solidFill>
+              <a:latin typeface="PingFang SC" panose="020B0400000000000000" charset="-122"/>
+            </a:endParaRPr>
           </a:p>
         </p:txBody>
       </p:sp>
@@ -6785,10 +7517,16 @@
                 <a:solidFill>
                   <a:srgbClr val="E8823C"/>
                 </a:solidFill>
-                <a:latin typeface="PingFang SC"/>
+                <a:latin typeface="PingFang SC" panose="020B0400000000000000" charset="-122"/>
               </a:rPr>
               <a:t>→</a:t>
             </a:r>
+            <a:endParaRPr sz="1800" b="1">
+              <a:solidFill>
+                <a:srgbClr val="E8823C"/>
+              </a:solidFill>
+              <a:latin typeface="PingFang SC" panose="020B0400000000000000" charset="-122"/>
+            </a:endParaRPr>
           </a:p>
         </p:txBody>
       </p:sp>
@@ -6833,7 +7571,7 @@
           </a:fontRef>
         </p:style>
         <p:txBody>
-          <a:bodyPr rtlCol="0" anchor="ctr" wrap="square" lIns="54864" rIns="54864"/>
+          <a:bodyPr wrap="square" lIns="54864" rIns="54864" rtlCol="0" anchor="ctr"/>
           <a:lstStyle/>
           <a:p>
             <a:pPr algn="ctr">
@@ -6846,10 +7584,16 @@
                 <a:solidFill>
                   <a:srgbClr val="2E3A45"/>
                 </a:solidFill>
-                <a:latin typeface="PingFang SC"/>
+                <a:latin typeface="PingFang SC" panose="020B0400000000000000" charset="-122"/>
               </a:rPr>
               <a:t>命中知识库模板</a:t>
             </a:r>
+            <a:endParaRPr sz="1500" b="0">
+              <a:solidFill>
+                <a:srgbClr val="2E3A45"/>
+              </a:solidFill>
+              <a:latin typeface="PingFang SC" panose="020B0400000000000000" charset="-122"/>
+            </a:endParaRPr>
           </a:p>
         </p:txBody>
       </p:sp>
@@ -6894,7 +7638,7 @@
           </a:fontRef>
         </p:style>
         <p:txBody>
-          <a:bodyPr rtlCol="0" anchor="ctr" wrap="square" lIns="54864" rIns="54864"/>
+          <a:bodyPr wrap="square" lIns="54864" rIns="54864" rtlCol="0" anchor="ctr"/>
           <a:lstStyle/>
           <a:p>
             <a:pPr algn="ctr">
@@ -6907,10 +7651,16 @@
                 <a:solidFill>
                   <a:srgbClr val="2E3A45"/>
                 </a:solidFill>
-                <a:latin typeface="PingFang SC"/>
+                <a:latin typeface="PingFang SC" panose="020B0400000000000000" charset="-122"/>
               </a:rPr>
               <a:t>速率 × 疲劳 × 难度</a:t>
             </a:r>
+            <a:endParaRPr sz="1500" b="0">
+              <a:solidFill>
+                <a:srgbClr val="2E3A45"/>
+              </a:solidFill>
+              <a:latin typeface="PingFang SC" panose="020B0400000000000000" charset="-122"/>
+            </a:endParaRPr>
           </a:p>
         </p:txBody>
       </p:sp>
@@ -6946,10 +7696,16 @@
                 <a:solidFill>
                   <a:srgbClr val="E8823C"/>
                 </a:solidFill>
-                <a:latin typeface="PingFang SC"/>
+                <a:latin typeface="PingFang SC" panose="020B0400000000000000" charset="-122"/>
               </a:rPr>
               <a:t>→</a:t>
             </a:r>
+            <a:endParaRPr sz="1800" b="1">
+              <a:solidFill>
+                <a:srgbClr val="E8823C"/>
+              </a:solidFill>
+              <a:latin typeface="PingFang SC" panose="020B0400000000000000" charset="-122"/>
+            </a:endParaRPr>
           </a:p>
         </p:txBody>
       </p:sp>
@@ -6994,7 +7750,7 @@
           </a:fontRef>
         </p:style>
         <p:txBody>
-          <a:bodyPr rtlCol="0" anchor="ctr" wrap="square" lIns="54864" rIns="54864"/>
+          <a:bodyPr wrap="square" lIns="54864" rIns="54864" rtlCol="0" anchor="ctr"/>
           <a:lstStyle/>
           <a:p>
             <a:pPr algn="ctr">
@@ -7007,10 +7763,16 @@
                 <a:solidFill>
                   <a:srgbClr val="2E3A45"/>
                 </a:solidFill>
-                <a:latin typeface="PingFang SC"/>
+                <a:latin typeface="PingFang SC" panose="020B0400000000000000" charset="-122"/>
               </a:rPr>
               <a:t>算出三档时长</a:t>
             </a:r>
+            <a:endParaRPr sz="1500" b="1">
+              <a:solidFill>
+                <a:srgbClr val="2E3A45"/>
+              </a:solidFill>
+              <a:latin typeface="PingFang SC" panose="020B0400000000000000" charset="-122"/>
+            </a:endParaRPr>
           </a:p>
         </p:txBody>
       </p:sp>
@@ -7046,10 +7808,16 @@
                 <a:solidFill>
                   <a:srgbClr val="E8823C"/>
                 </a:solidFill>
-                <a:latin typeface="PingFang SC"/>
+                <a:latin typeface="PingFang SC" panose="020B0400000000000000" charset="-122"/>
               </a:rPr>
               <a:t>→</a:t>
             </a:r>
+            <a:endParaRPr sz="1800" b="1">
+              <a:solidFill>
+                <a:srgbClr val="E8823C"/>
+              </a:solidFill>
+              <a:latin typeface="PingFang SC" panose="020B0400000000000000" charset="-122"/>
+            </a:endParaRPr>
           </a:p>
         </p:txBody>
       </p:sp>
@@ -7094,7 +7862,7 @@
           </a:fontRef>
         </p:style>
         <p:txBody>
-          <a:bodyPr rtlCol="0" anchor="ctr" wrap="square" lIns="54864" rIns="54864"/>
+          <a:bodyPr wrap="square" lIns="54864" rIns="54864" rtlCol="0" anchor="ctr"/>
           <a:lstStyle/>
           <a:p>
             <a:pPr algn="ctr">
@@ -7107,10 +7875,16 @@
                 <a:solidFill>
                   <a:srgbClr val="2E3A45"/>
                 </a:solidFill>
-                <a:latin typeface="PingFang SC"/>
+                <a:latin typeface="PingFang SC" panose="020B0400000000000000" charset="-122"/>
               </a:rPr>
               <a:t>AI 只能微调 ±15%</a:t>
             </a:r>
+            <a:endParaRPr sz="1500" b="0">
+              <a:solidFill>
+                <a:srgbClr val="2E3A45"/>
+              </a:solidFill>
+              <a:latin typeface="PingFang SC" panose="020B0400000000000000" charset="-122"/>
+            </a:endParaRPr>
           </a:p>
         </p:txBody>
       </p:sp>
@@ -7146,10 +7920,16 @@
                 <a:solidFill>
                   <a:srgbClr val="E8823C"/>
                 </a:solidFill>
-                <a:latin typeface="PingFang SC"/>
+                <a:latin typeface="PingFang SC" panose="020B0400000000000000" charset="-122"/>
               </a:rPr>
               <a:t>305</a:t>
             </a:r>
+            <a:endParaRPr sz="4400" b="1">
+              <a:solidFill>
+                <a:srgbClr val="E8823C"/>
+              </a:solidFill>
+              <a:latin typeface="PingFang SC" panose="020B0400000000000000" charset="-122"/>
+            </a:endParaRPr>
           </a:p>
         </p:txBody>
       </p:sp>
@@ -7185,10 +7965,16 @@
                 <a:solidFill>
                   <a:srgbClr val="61707C"/>
                 </a:solidFill>
-                <a:latin typeface="PingFang SC"/>
+                <a:latin typeface="PingFang SC" panose="020B0400000000000000" charset="-122"/>
               </a:rPr>
               <a:t>最快（分钟）</a:t>
             </a:r>
+            <a:endParaRPr sz="1500" b="0">
+              <a:solidFill>
+                <a:srgbClr val="61707C"/>
+              </a:solidFill>
+              <a:latin typeface="PingFang SC" panose="020B0400000000000000" charset="-122"/>
+            </a:endParaRPr>
           </a:p>
         </p:txBody>
       </p:sp>
@@ -7224,10 +8010,16 @@
                 <a:solidFill>
                   <a:srgbClr val="E8823C"/>
                 </a:solidFill>
-                <a:latin typeface="PingFang SC"/>
+                <a:latin typeface="PingFang SC" panose="020B0400000000000000" charset="-122"/>
               </a:rPr>
               <a:t>375</a:t>
             </a:r>
+            <a:endParaRPr sz="4400" b="1">
+              <a:solidFill>
+                <a:srgbClr val="E8823C"/>
+              </a:solidFill>
+              <a:latin typeface="PingFang SC" panose="020B0400000000000000" charset="-122"/>
+            </a:endParaRPr>
           </a:p>
         </p:txBody>
       </p:sp>
@@ -7263,10 +8055,16 @@
                 <a:solidFill>
                   <a:srgbClr val="61707C"/>
                 </a:solidFill>
-                <a:latin typeface="PingFang SC"/>
+                <a:latin typeface="PingFang SC" panose="020B0400000000000000" charset="-122"/>
               </a:rPr>
               <a:t>常见（分钟）</a:t>
             </a:r>
+            <a:endParaRPr sz="1500" b="0">
+              <a:solidFill>
+                <a:srgbClr val="61707C"/>
+              </a:solidFill>
+              <a:latin typeface="PingFang SC" panose="020B0400000000000000" charset="-122"/>
+            </a:endParaRPr>
           </a:p>
         </p:txBody>
       </p:sp>
@@ -7302,10 +8100,16 @@
                 <a:solidFill>
                   <a:srgbClr val="E8823C"/>
                 </a:solidFill>
-                <a:latin typeface="PingFang SC"/>
+                <a:latin typeface="PingFang SC" panose="020B0400000000000000" charset="-122"/>
               </a:rPr>
               <a:t>461</a:t>
             </a:r>
+            <a:endParaRPr sz="4400" b="1">
+              <a:solidFill>
+                <a:srgbClr val="E8823C"/>
+              </a:solidFill>
+              <a:latin typeface="PingFang SC" panose="020B0400000000000000" charset="-122"/>
+            </a:endParaRPr>
           </a:p>
         </p:txBody>
       </p:sp>
@@ -7341,10 +8145,16 @@
                 <a:solidFill>
                   <a:srgbClr val="61707C"/>
                 </a:solidFill>
-                <a:latin typeface="PingFang SC"/>
+                <a:latin typeface="PingFang SC" panose="020B0400000000000000" charset="-122"/>
               </a:rPr>
               <a:t>最慢（分钟）</a:t>
             </a:r>
+            <a:endParaRPr sz="1500" b="0">
+              <a:solidFill>
+                <a:srgbClr val="61707C"/>
+              </a:solidFill>
+              <a:latin typeface="PingFang SC" panose="020B0400000000000000" charset="-122"/>
+            </a:endParaRPr>
           </a:p>
         </p:txBody>
       </p:sp>
@@ -7429,7 +8239,7 @@
           </a:fontRef>
         </p:style>
         <p:txBody>
-          <a:bodyPr rtlCol="0" anchor="ctr" wrap="square" lIns="256032"/>
+          <a:bodyPr wrap="square" lIns="256032" rtlCol="0" anchor="ctr"/>
           <a:lstStyle/>
           <a:p>
             <a:pPr algn="ctr"/>
@@ -7438,10 +8248,16 @@
                 <a:solidFill>
                   <a:srgbClr val="2E3A45"/>
                 </a:solidFill>
-                <a:latin typeface="PingFang SC"/>
+                <a:latin typeface="PingFang SC" panose="020B0400000000000000" charset="-122"/>
               </a:rPr>
               <a:t>不是让 AI 拍脑袋估时间，是让它在有证据的区间里做小幅校准。</a:t>
             </a:r>
+            <a:endParaRPr sz="2100" b="1">
+              <a:solidFill>
+                <a:srgbClr val="2E3A45"/>
+              </a:solidFill>
+              <a:latin typeface="PingFang SC" panose="020B0400000000000000" charset="-122"/>
+            </a:endParaRPr>
           </a:p>
         </p:txBody>
       </p:sp>
@@ -7453,8 +8269,8 @@
 </p:sld>
 </file>
 
-<file path=ppt/slides/slide7.xml><?xml version="1.0" encoding="utf-8"?>
-<p:sld xmlns:a="http://schemas.openxmlformats.org/drawingml/2006/main" xmlns:p="http://schemas.openxmlformats.org/presentationml/2006/main" xmlns:r="http://schemas.openxmlformats.org/officeDocument/2006/relationships">
+<file path=ppt/slides/slide8.xml><?xml version="1.0" encoding="utf-8"?>
+<p:sld xmlns:a="http://schemas.openxmlformats.org/drawingml/2006/main" xmlns:r="http://schemas.openxmlformats.org/officeDocument/2006/relationships" xmlns:p="http://schemas.openxmlformats.org/presentationml/2006/main">
   <p:cSld>
     <p:spTree>
       <p:nvGrpSpPr>
@@ -7486,7 +8302,7 @@
                 <a:srgbClr val="F7F2E0"/>
               </a:gs>
             </a:gsLst>
-            <a:lin scaled="0" ang="16200000"/>
+            <a:lin ang="16200000" scaled="0"/>
           </a:gradFill>
           <a:ln>
             <a:noFill/>
@@ -7547,10 +8363,16 @@
                 <a:solidFill>
                   <a:srgbClr val="2E3A45"/>
                 </a:solidFill>
-                <a:latin typeface="PingFang SC"/>
+                <a:latin typeface="PingFang SC" panose="020B0400000000000000" charset="-122"/>
               </a:rPr>
-              <a:t>一次真实的崩溃，和我现在的边界</a:t>
-            </a:r>
+              <a:t>下一步，以及我想找的两个人</a:t>
+            </a:r>
+            <a:endParaRPr sz="4000" b="1">
+              <a:solidFill>
+                <a:srgbClr val="2E3A45"/>
+              </a:solidFill>
+              <a:latin typeface="PingFang SC" panose="020B0400000000000000" charset="-122"/>
+            </a:endParaRPr>
           </a:p>
         </p:txBody>
       </p:sp>
@@ -7562,8 +8384,8 @@
         </p:nvSpPr>
         <p:spPr>
           <a:xfrm>
-            <a:off x="713232" y="1691640"/>
-            <a:ext cx="3393338" cy="1874519"/>
+            <a:off x="713232" y="1572768"/>
+            <a:ext cx="10765231" cy="868680"/>
           </a:xfrm>
           <a:prstGeom prst="roundRect">
             <a:avLst>
@@ -7595,7 +8417,7 @@
           </a:fontRef>
         </p:style>
         <p:txBody>
-          <a:bodyPr rtlCol="0" anchor="ctr" wrap="square" lIns="219456" rIns="219456" tIns="146304" bIns="146304"/>
+          <a:bodyPr wrap="square" lIns="219456" tIns="146304" rIns="219456" bIns="146304" rtlCol="0" anchor="ctr"/>
           <a:lstStyle/>
           <a:p>
             <a:pPr algn="ctr">
@@ -7608,10 +8430,16 @@
                 <a:solidFill>
                   <a:srgbClr val="61707C"/>
                 </a:solidFill>
-                <a:latin typeface="PingFang SC"/>
+                <a:latin typeface="PingFang SC" panose="020B0400000000000000" charset="-122"/>
               </a:rPr>
-              <a:t>现象</a:t>
-            </a:r>
+              <a:t>现在做到了</a:t>
+            </a:r>
+            <a:endParaRPr sz="1300" b="0">
+              <a:solidFill>
+                <a:srgbClr val="61707C"/>
+              </a:solidFill>
+              <a:latin typeface="PingFang SC" panose="020B0400000000000000" charset="-122"/>
+            </a:endParaRPr>
           </a:p>
           <a:p>
             <a:pPr>
@@ -7620,440 +8448,20 @@
               </a:lnSpc>
             </a:pPr>
             <a:r>
-              <a:rPr sz="1800" b="0">
+              <a:rPr sz="1700" b="0">
                 <a:solidFill>
                   <a:srgbClr val="2E3A45"/>
                 </a:solidFill>
-                <a:latin typeface="PingFang SC"/>
-              </a:rPr>
-              <a:t>后端刚启动时第一个请求会连接超时，1.0 直接崩掉，页面一片空白</a:t>
-            </a:r>
-          </a:p>
-        </p:txBody>
-      </p:sp>
-      <p:sp>
-        <p:nvSpPr>
-          <p:cNvPr id="5" name="Rounded Rectangle 4"/>
-          <p:cNvSpPr/>
-          <p:nvPr/>
-        </p:nvSpPr>
-        <p:spPr>
-          <a:xfrm>
-            <a:off x="4399178" y="1691640"/>
-            <a:ext cx="3393338" cy="1874519"/>
-          </a:xfrm>
-          <a:prstGeom prst="roundRect">
-            <a:avLst>
-              <a:gd name="adj" fmla="val 9000"/>
-            </a:avLst>
-          </a:prstGeom>
-          <a:solidFill>
-            <a:srgbClr val="FFFFFF"/>
-          </a:solidFill>
-          <a:ln w="12700">
-            <a:solidFill>
-              <a:srgbClr val="E4ECF2"/>
-            </a:solidFill>
-          </a:ln>
-          <a:effectLst/>
-        </p:spPr>
-        <p:style>
-          <a:lnRef idx="1">
-            <a:schemeClr val="accent1"/>
-          </a:lnRef>
-          <a:fillRef idx="3">
-            <a:schemeClr val="accent1"/>
-          </a:fillRef>
-          <a:effectRef idx="2">
-            <a:schemeClr val="accent1"/>
-          </a:effectRef>
-          <a:fontRef idx="minor">
-            <a:schemeClr val="lt1"/>
-          </a:fontRef>
-        </p:style>
-        <p:txBody>
-          <a:bodyPr rtlCol="0" anchor="ctr" wrap="square" lIns="219456" rIns="219456" tIns="146304" bIns="146304"/>
-          <a:lstStyle/>
-          <a:p>
-            <a:pPr algn="ctr">
-              <a:lnSpc>
-                <a:spcPct val="135000"/>
-              </a:lnSpc>
-            </a:pPr>
-            <a:r>
-              <a:rPr sz="1300" b="0">
-                <a:solidFill>
-                  <a:srgbClr val="61707C"/>
-                </a:solidFill>
-                <a:latin typeface="PingFang SC"/>
-              </a:rPr>
-              <a:t>修改</a:t>
-            </a:r>
-          </a:p>
-          <a:p>
-            <a:pPr>
-              <a:lnSpc>
-                <a:spcPct val="135000"/>
-              </a:lnSpc>
-            </a:pPr>
-            <a:r>
-              <a:rPr sz="1800" b="0">
-                <a:solidFill>
-                  <a:srgbClr val="2E3A45"/>
-                </a:solidFill>
-                <a:latin typeface="PingFang SC"/>
-              </a:rPr>
-              <a:t>请求前先花 3 秒探活，模型不可用就返回一句中文提示，超时单独处理</a:t>
-            </a:r>
-          </a:p>
-        </p:txBody>
-      </p:sp>
-      <p:sp>
-        <p:nvSpPr>
-          <p:cNvPr id="6" name="Rounded Rectangle 5"/>
-          <p:cNvSpPr/>
-          <p:nvPr/>
-        </p:nvSpPr>
-        <p:spPr>
-          <a:xfrm>
-            <a:off x="8085124" y="1691640"/>
-            <a:ext cx="3393338" cy="1874519"/>
-          </a:xfrm>
-          <a:prstGeom prst="roundRect">
-            <a:avLst>
-              <a:gd name="adj" fmla="val 9000"/>
-            </a:avLst>
-          </a:prstGeom>
-          <a:solidFill>
-            <a:srgbClr val="FFFFFF"/>
-          </a:solidFill>
-          <a:ln w="12700">
-            <a:solidFill>
-              <a:srgbClr val="E4ECF2"/>
-            </a:solidFill>
-          </a:ln>
-          <a:effectLst/>
-        </p:spPr>
-        <p:style>
-          <a:lnRef idx="1">
-            <a:schemeClr val="accent1"/>
-          </a:lnRef>
-          <a:fillRef idx="3">
-            <a:schemeClr val="accent1"/>
-          </a:fillRef>
-          <a:effectRef idx="2">
-            <a:schemeClr val="accent1"/>
-          </a:effectRef>
-          <a:fontRef idx="minor">
-            <a:schemeClr val="lt1"/>
-          </a:fontRef>
-        </p:style>
-        <p:txBody>
-          <a:bodyPr rtlCol="0" anchor="ctr" wrap="square" lIns="219456" rIns="219456" tIns="146304" bIns="146304"/>
-          <a:lstStyle/>
-          <a:p>
-            <a:pPr algn="ctr">
-              <a:lnSpc>
-                <a:spcPct val="135000"/>
-              </a:lnSpc>
-            </a:pPr>
-            <a:r>
-              <a:rPr sz="1300" b="0">
-                <a:solidFill>
-                  <a:srgbClr val="61707C"/>
-                </a:solidFill>
-                <a:latin typeface="PingFang SC"/>
-              </a:rPr>
-              <a:t>结果</a:t>
-            </a:r>
-          </a:p>
-          <a:p>
-            <a:pPr>
-              <a:lnSpc>
-                <a:spcPct val="135000"/>
-              </a:lnSpc>
-            </a:pPr>
-            <a:r>
-              <a:rPr sz="1800" b="0">
-                <a:solidFill>
-                  <a:srgbClr val="2E3A45"/>
-                </a:solidFill>
-                <a:latin typeface="PingFang SC"/>
-              </a:rPr>
-              <a:t>最坏情况是看到一句「DeepSeek 暂时不可用」，产品还在，</a:t>
-            </a:r>
-            <a:r>
-              <a:rPr sz="1800" b="1">
-                <a:solidFill>
-                  <a:srgbClr val="E8823C"/>
-                </a:solidFill>
-                <a:latin typeface="PingFang SC"/>
-              </a:rPr>
-              <a:t>不会白屏</a:t>
-            </a:r>
-          </a:p>
-        </p:txBody>
-      </p:sp>
-      <p:sp>
-        <p:nvSpPr>
-          <p:cNvPr id="7" name="Rounded Rectangle 6"/>
-          <p:cNvSpPr/>
-          <p:nvPr/>
-        </p:nvSpPr>
-        <p:spPr>
-          <a:xfrm>
-            <a:off x="713232" y="3931920"/>
-            <a:ext cx="10765231" cy="1234440"/>
-          </a:xfrm>
-          <a:prstGeom prst="roundRect">
-            <a:avLst>
-              <a:gd name="adj" fmla="val 9000"/>
-            </a:avLst>
-          </a:prstGeom>
-          <a:solidFill>
-            <a:srgbClr val="F6F4EE"/>
-          </a:solidFill>
-          <a:ln w="12700">
-            <a:solidFill>
-              <a:srgbClr val="E4ECF2"/>
-            </a:solidFill>
-          </a:ln>
-          <a:effectLst/>
-        </p:spPr>
-        <p:style>
-          <a:lnRef idx="1">
-            <a:schemeClr val="accent1"/>
-          </a:lnRef>
-          <a:fillRef idx="3">
-            <a:schemeClr val="accent1"/>
-          </a:fillRef>
-          <a:effectRef idx="2">
-            <a:schemeClr val="accent1"/>
-          </a:effectRef>
-          <a:fontRef idx="minor">
-            <a:schemeClr val="lt1"/>
-          </a:fontRef>
-        </p:style>
-        <p:txBody>
-          <a:bodyPr rtlCol="0" anchor="ctr" wrap="square" lIns="219456" rIns="219456" tIns="146304" bIns="146304"/>
-          <a:lstStyle/>
-          <a:p>
-            <a:pPr algn="ctr">
-              <a:lnSpc>
-                <a:spcPct val="135000"/>
-              </a:lnSpc>
-            </a:pPr>
-            <a:r>
-              <a:rPr sz="1300" b="0">
-                <a:solidFill>
-                  <a:srgbClr val="61707C"/>
-                </a:solidFill>
-                <a:latin typeface="PingFang SC"/>
-              </a:rPr>
-              <a:t>我还没解决的</a:t>
-            </a:r>
-          </a:p>
-          <a:p>
-            <a:pPr>
-              <a:lnSpc>
-                <a:spcPct val="135000"/>
-              </a:lnSpc>
-            </a:pPr>
-            <a:r>
-              <a:rPr sz="1800" b="0">
-                <a:solidFill>
-                  <a:srgbClr val="2E3A45"/>
-                </a:solidFill>
-                <a:latin typeface="PingFang SC"/>
-              </a:rPr>
-              <a:t>失败后不会自动重试，得手动再发一次　·　对话没有逐字输出　·　估时的检索还比较粗糙</a:t>
-            </a:r>
-          </a:p>
-        </p:txBody>
-      </p:sp>
-    </p:spTree>
-  </p:cSld>
-  <p:clrMapOvr>
-    <a:masterClrMapping/>
-  </p:clrMapOvr>
-</p:sld>
-</file>
-
-<file path=ppt/slides/slide8.xml><?xml version="1.0" encoding="utf-8"?>
-<p:sld xmlns:a="http://schemas.openxmlformats.org/drawingml/2006/main" xmlns:p="http://schemas.openxmlformats.org/presentationml/2006/main" xmlns:r="http://schemas.openxmlformats.org/officeDocument/2006/relationships">
-  <p:cSld>
-    <p:spTree>
-      <p:nvGrpSpPr>
-        <p:cNvPr id="1" name=""/>
-        <p:cNvGrpSpPr/>
-        <p:nvPr/>
-      </p:nvGrpSpPr>
-      <p:grpSpPr/>
-      <p:sp>
-        <p:nvSpPr>
-          <p:cNvPr id="2" name="Rectangle 1"/>
-          <p:cNvSpPr/>
-          <p:nvPr/>
-        </p:nvSpPr>
-        <p:spPr>
-          <a:xfrm>
-            <a:off x="0" y="0"/>
-            <a:ext cx="12191695" cy="6858000"/>
-          </a:xfrm>
-          <a:prstGeom prst="rect">
-            <a:avLst/>
-          </a:prstGeom>
-          <a:gradFill rotWithShape="1">
-            <a:gsLst>
-              <a:gs pos="0">
-                <a:srgbClr val="A8D8F0"/>
-              </a:gs>
-              <a:gs pos="100000">
-                <a:srgbClr val="F7F2E0"/>
-              </a:gs>
-            </a:gsLst>
-            <a:lin scaled="0" ang="16200000"/>
-          </a:gradFill>
-          <a:ln>
-            <a:noFill/>
-          </a:ln>
-          <a:effectLst/>
-        </p:spPr>
-        <p:style>
-          <a:lnRef idx="1">
-            <a:schemeClr val="accent1"/>
-          </a:lnRef>
-          <a:fillRef idx="3">
-            <a:schemeClr val="accent1"/>
-          </a:fillRef>
-          <a:effectRef idx="2">
-            <a:schemeClr val="accent1"/>
-          </a:effectRef>
-          <a:fontRef idx="minor">
-            <a:schemeClr val="lt1"/>
-          </a:fontRef>
-        </p:style>
-        <p:txBody>
-          <a:bodyPr rtlCol="0" anchor="ctr"/>
-          <a:lstStyle/>
-          <a:p>
-            <a:pPr algn="ctr"/>
-          </a:p>
-        </p:txBody>
-      </p:sp>
-      <p:sp>
-        <p:nvSpPr>
-          <p:cNvPr id="3" name="TextBox 2"/>
-          <p:cNvSpPr txBox="1"/>
-          <p:nvPr/>
-        </p:nvSpPr>
-        <p:spPr>
-          <a:xfrm>
-            <a:off x="713232" y="566928"/>
-            <a:ext cx="10765231" cy="914400"/>
-          </a:xfrm>
-          <a:prstGeom prst="rect">
-            <a:avLst/>
-          </a:prstGeom>
-          <a:noFill/>
-        </p:spPr>
-        <p:txBody>
-          <a:bodyPr wrap="square" anchor="t">
-            <a:spAutoFit/>
-          </a:bodyPr>
-          <a:lstStyle/>
-          <a:p>
-            <a:pPr algn="l">
-              <a:lnSpc>
-                <a:spcPct val="120000"/>
-              </a:lnSpc>
-            </a:pPr>
-            <a:r>
-              <a:rPr sz="4000" b="1">
-                <a:solidFill>
-                  <a:srgbClr val="2E3A45"/>
-                </a:solidFill>
-                <a:latin typeface="PingFang SC"/>
-              </a:rPr>
-              <a:t>下一步，以及我想找的两个人</a:t>
-            </a:r>
-          </a:p>
-        </p:txBody>
-      </p:sp>
-      <p:sp>
-        <p:nvSpPr>
-          <p:cNvPr id="4" name="Rounded Rectangle 3"/>
-          <p:cNvSpPr/>
-          <p:nvPr/>
-        </p:nvSpPr>
-        <p:spPr>
-          <a:xfrm>
-            <a:off x="713232" y="1572768"/>
-            <a:ext cx="10765231" cy="868680"/>
-          </a:xfrm>
-          <a:prstGeom prst="roundRect">
-            <a:avLst>
-              <a:gd name="adj" fmla="val 9000"/>
-            </a:avLst>
-          </a:prstGeom>
-          <a:solidFill>
-            <a:srgbClr val="FFFFFF"/>
-          </a:solidFill>
-          <a:ln w="12700">
-            <a:solidFill>
-              <a:srgbClr val="E4ECF2"/>
-            </a:solidFill>
-          </a:ln>
-          <a:effectLst/>
-        </p:spPr>
-        <p:style>
-          <a:lnRef idx="1">
-            <a:schemeClr val="accent1"/>
-          </a:lnRef>
-          <a:fillRef idx="3">
-            <a:schemeClr val="accent1"/>
-          </a:fillRef>
-          <a:effectRef idx="2">
-            <a:schemeClr val="accent1"/>
-          </a:effectRef>
-          <a:fontRef idx="minor">
-            <a:schemeClr val="lt1"/>
-          </a:fontRef>
-        </p:style>
-        <p:txBody>
-          <a:bodyPr rtlCol="0" anchor="ctr" wrap="square" lIns="219456" rIns="219456" tIns="146304" bIns="146304"/>
-          <a:lstStyle/>
-          <a:p>
-            <a:pPr algn="ctr">
-              <a:lnSpc>
-                <a:spcPct val="135000"/>
-              </a:lnSpc>
-            </a:pPr>
-            <a:r>
-              <a:rPr sz="1300" b="0">
-                <a:solidFill>
-                  <a:srgbClr val="61707C"/>
-                </a:solidFill>
-                <a:latin typeface="PingFang SC"/>
-              </a:rPr>
-              <a:t>现在做到了</a:t>
-            </a:r>
-          </a:p>
-          <a:p>
-            <a:pPr>
-              <a:lnSpc>
-                <a:spcPct val="135000"/>
-              </a:lnSpc>
-            </a:pPr>
-            <a:r>
-              <a:rPr sz="1700" b="0">
-                <a:solidFill>
-                  <a:srgbClr val="2E3A45"/>
-                </a:solidFill>
-                <a:latin typeface="PingFang SC"/>
+                <a:latin typeface="PingFang SC" panose="020B0400000000000000" charset="-122"/>
               </a:rPr>
               <a:t>端到端闭环可用　·　知识库 329 条　·　2 个不用联网就能跑的测试　·　3 组估时用例全过</a:t>
             </a:r>
+            <a:endParaRPr sz="1700" b="0">
+              <a:solidFill>
+                <a:srgbClr val="2E3A45"/>
+              </a:solidFill>
+              <a:latin typeface="PingFang SC" panose="020B0400000000000000" charset="-122"/>
+            </a:endParaRPr>
           </a:p>
         </p:txBody>
       </p:sp>
@@ -8098,7 +8506,7 @@
           </a:fontRef>
         </p:style>
         <p:txBody>
-          <a:bodyPr rtlCol="0" anchor="ctr" wrap="square" lIns="219456" rIns="219456" tIns="146304" bIns="146304"/>
+          <a:bodyPr wrap="square" lIns="219456" tIns="146304" rIns="219456" bIns="146304" rtlCol="0" anchor="ctr"/>
           <a:lstStyle/>
           <a:p>
             <a:pPr algn="ctr">
@@ -8111,10 +8519,16 @@
                 <a:solidFill>
                   <a:srgbClr val="61707C"/>
                 </a:solidFill>
-                <a:latin typeface="PingFang SC"/>
+                <a:latin typeface="PingFang SC" panose="020B0400000000000000" charset="-122"/>
               </a:rPr>
               <a:t>知识库数据伙伴　不需要写代码</a:t>
             </a:r>
+            <a:endParaRPr sz="1300" b="0">
+              <a:solidFill>
+                <a:srgbClr val="61707C"/>
+              </a:solidFill>
+              <a:latin typeface="PingFang SC" panose="020B0400000000000000" charset="-122"/>
+            </a:endParaRPr>
           </a:p>
           <a:p>
             <a:pPr>
@@ -8127,7 +8541,7 @@
                 <a:solidFill>
                   <a:srgbClr val="2E3A45"/>
                 </a:solidFill>
-                <a:latin typeface="PingFang SC"/>
+                <a:latin typeface="PingFang SC" panose="020B0400000000000000" charset="-122"/>
               </a:rPr>
               <a:t>我已经做好了问卷，你帮我收 </a:t>
             </a:r>
@@ -8136,7 +8550,7 @@
                 <a:solidFill>
                   <a:srgbClr val="E8823C"/>
                 </a:solidFill>
-                <a:latin typeface="PingFang SC"/>
+                <a:latin typeface="PingFang SC" panose="020B0400000000000000" charset="-122"/>
               </a:rPr>
               <a:t>30 份</a:t>
             </a:r>
@@ -8145,10 +8559,16 @@
                 <a:solidFill>
                   <a:srgbClr val="2E3A45"/>
                 </a:solidFill>
-                <a:latin typeface="PingFang SC"/>
+                <a:latin typeface="PingFang SC" panose="020B0400000000000000" charset="-122"/>
               </a:rPr>
               <a:t>真实高中生的任务耗时，补进知识库当校准案例</a:t>
             </a:r>
+            <a:endParaRPr sz="1900" b="0">
+              <a:solidFill>
+                <a:srgbClr val="2E3A45"/>
+              </a:solidFill>
+              <a:latin typeface="PingFang SC" panose="020B0400000000000000" charset="-122"/>
+            </a:endParaRPr>
           </a:p>
         </p:txBody>
       </p:sp>
@@ -8193,7 +8613,7 @@
           </a:fontRef>
         </p:style>
         <p:txBody>
-          <a:bodyPr rtlCol="0" anchor="ctr" wrap="square" lIns="219456" rIns="219456" tIns="146304" bIns="146304"/>
+          <a:bodyPr wrap="square" lIns="219456" tIns="146304" rIns="219456" bIns="146304" rtlCol="0" anchor="ctr"/>
           <a:lstStyle/>
           <a:p>
             <a:pPr algn="ctr">
@@ -8206,10 +8626,16 @@
                 <a:solidFill>
                   <a:srgbClr val="61707C"/>
                 </a:solidFill>
-                <a:latin typeface="PingFang SC"/>
+                <a:latin typeface="PingFang SC" panose="020B0400000000000000" charset="-122"/>
               </a:rPr>
               <a:t>评测伙伴</a:t>
             </a:r>
+            <a:endParaRPr sz="1300" b="0">
+              <a:solidFill>
+                <a:srgbClr val="61707C"/>
+              </a:solidFill>
+              <a:latin typeface="PingFang SC" panose="020B0400000000000000" charset="-122"/>
+            </a:endParaRPr>
           </a:p>
           <a:p>
             <a:pPr>
@@ -8222,7 +8648,7 @@
                 <a:solidFill>
                   <a:srgbClr val="2E3A45"/>
                 </a:solidFill>
-                <a:latin typeface="PingFang SC"/>
+                <a:latin typeface="PingFang SC" panose="020B0400000000000000" charset="-122"/>
               </a:rPr>
               <a:t>估时现在只有 3 组用例，你帮我扩到 </a:t>
             </a:r>
@@ -8231,7 +8657,7 @@
                 <a:solidFill>
                   <a:srgbClr val="E8823C"/>
                 </a:solidFill>
-                <a:latin typeface="PingFang SC"/>
+                <a:latin typeface="PingFang SC" panose="020B0400000000000000" charset="-122"/>
               </a:rPr>
               <a:t>30 组以上</a:t>
             </a:r>
@@ -8240,10 +8666,16 @@
                 <a:solidFill>
                   <a:srgbClr val="2E3A45"/>
                 </a:solidFill>
-                <a:latin typeface="PingFang SC"/>
+                <a:latin typeface="PingFang SC" panose="020B0400000000000000" charset="-122"/>
               </a:rPr>
               <a:t>，写成一条命令跑完的自动回归，让「变准了」有数可证</a:t>
             </a:r>
+            <a:endParaRPr sz="1900" b="0">
+              <a:solidFill>
+                <a:srgbClr val="2E3A45"/>
+              </a:solidFill>
+              <a:latin typeface="PingFang SC" panose="020B0400000000000000" charset="-122"/>
+            </a:endParaRPr>
           </a:p>
         </p:txBody>
       </p:sp>
@@ -8279,121 +8711,16 @@
                 <a:solidFill>
                   <a:srgbClr val="E8823C"/>
                 </a:solidFill>
-                <a:latin typeface="PingFang SC"/>
+                <a:latin typeface="PingFang SC" panose="020B0400000000000000" charset="-122"/>
               </a:rPr>
               <a:t>把大任务拆小，把计划变行动。</a:t>
             </a:r>
-          </a:p>
-        </p:txBody>
-      </p:sp>
-      <p:sp>
-        <p:nvSpPr>
-          <p:cNvPr id="8" name="Rounded Rectangle 7"/>
-          <p:cNvSpPr/>
-          <p:nvPr/>
-        </p:nvSpPr>
-        <p:spPr>
-          <a:xfrm>
-            <a:off x="10344607" y="5358384"/>
-            <a:ext cx="1216152" cy="1527048"/>
-          </a:xfrm>
-          <a:prstGeom prst="roundRect">
-            <a:avLst>
-              <a:gd name="adj" fmla="val 9000"/>
-            </a:avLst>
-          </a:prstGeom>
-          <a:solidFill>
-            <a:srgbClr val="FFFFFF"/>
-          </a:solidFill>
-          <a:ln>
-            <a:solidFill>
-              <a:srgbClr val="E4ECF2"/>
-            </a:solidFill>
-          </a:ln>
-          <a:effectLst/>
-        </p:spPr>
-        <p:style>
-          <a:lnRef idx="1">
-            <a:schemeClr val="accent1"/>
-          </a:lnRef>
-          <a:fillRef idx="3">
-            <a:schemeClr val="accent1"/>
-          </a:fillRef>
-          <a:effectRef idx="2">
-            <a:schemeClr val="accent1"/>
-          </a:effectRef>
-          <a:fontRef idx="minor">
-            <a:schemeClr val="lt1"/>
-          </a:fontRef>
-        </p:style>
-        <p:txBody>
-          <a:bodyPr rtlCol="0" anchor="ctr"/>
-          <a:lstStyle/>
-          <a:p>
-            <a:pPr algn="ctr"/>
-          </a:p>
-        </p:txBody>
-      </p:sp>
-      <p:pic>
-        <p:nvPicPr>
-          <p:cNvPr id="9" name="Picture 8" descr="qr_github.png"/>
-          <p:cNvPicPr>
-            <a:picLocks noChangeAspect="1"/>
-          </p:cNvPicPr>
-          <p:nvPr/>
-        </p:nvPicPr>
-        <p:blipFill>
-          <a:blip r:embed="rId3"/>
-          <a:stretch>
-            <a:fillRect/>
-          </a:stretch>
-        </p:blipFill>
-        <p:spPr>
-          <a:xfrm>
-            <a:off x="10426903" y="5440680"/>
-            <a:ext cx="1051560" cy="1051560"/>
-          </a:xfrm>
-          <a:prstGeom prst="rect">
-            <a:avLst/>
-          </a:prstGeom>
-        </p:spPr>
-      </p:pic>
-      <p:sp>
-        <p:nvSpPr>
-          <p:cNvPr id="10" name="TextBox 9"/>
-          <p:cNvSpPr txBox="1"/>
-          <p:nvPr/>
-        </p:nvSpPr>
-        <p:spPr>
-          <a:xfrm>
-            <a:off x="10061143" y="6492240"/>
-            <a:ext cx="1783080" cy="274320"/>
-          </a:xfrm>
-          <a:prstGeom prst="rect">
-            <a:avLst/>
-          </a:prstGeom>
-          <a:noFill/>
-        </p:spPr>
-        <p:txBody>
-          <a:bodyPr wrap="square" anchor="t">
-            <a:spAutoFit/>
-          </a:bodyPr>
-          <a:lstStyle/>
-          <a:p>
-            <a:pPr algn="ctr">
-              <a:lnSpc>
-                <a:spcPct val="125000"/>
-              </a:lnSpc>
-            </a:pPr>
-            <a:r>
-              <a:rPr sz="1000" b="0">
-                <a:solidFill>
-                  <a:srgbClr val="61707C"/>
-                </a:solidFill>
-                <a:latin typeface="PingFang SC"/>
-              </a:rPr>
-              <a:t>github.com/diaq011/P2J</a:t>
-            </a:r>
+            <a:endParaRPr sz="2400" b="1">
+              <a:solidFill>
+                <a:srgbClr val="E8823C"/>
+              </a:solidFill>
+              <a:latin typeface="PingFang SC" panose="020B0400000000000000" charset="-122"/>
+            </a:endParaRPr>
           </a:p>
         </p:txBody>
       </p:sp>
@@ -8721,7 +9048,11 @@
       </a:style>
     </a:lnDef>
   </a:objectDefaults>
-  <a:extraClrSchemeLst/>
+  <a:extLst>
+    <a:ext uri="{05A4C25C-085E-4340-85A3-A5531E510DB2}">
+      <thm15:themeFamily xmlns:thm15="http://schemas.microsoft.com/office/thememl/2012/main" name="Office Theme" id="{62F939B6-93AF-4DB8-9C6B-D6C7DFDC589F}" vid="{4A3C46E8-61CC-4603-A589-7422A47A8E4A}"/>
+    </a:ext>
+  </a:extLst>
 </a:theme>
 </file>
 
@@ -9041,6 +9372,10 @@
       </a:style>
     </a:lnDef>
   </a:objectDefaults>
-  <a:extraClrSchemeLst/>
+  <a:extLst>
+    <a:ext uri="{05A4C25C-085E-4340-85A3-A5531E510DB2}">
+      <thm15:themeFamily xmlns:thm15="http://schemas.microsoft.com/office/thememl/2012/main" name="Office Theme" id="{62F939B6-93AF-4DB8-9C6B-D6C7DFDC589F}" vid="{4A3C46E8-61CC-4603-A589-7422A47A8E4A}"/>
+    </a:ext>
+  </a:extLst>
 </a:theme>
 </file>
</xml_diff>